<commit_message>
Simplify lecture plan slide, align text, add tool/reference links
Co-Authored-By: Claude Opus 5.5 <noreply@anthropic.com>
Claude-Session: https://claude.ai/code/session_01Co17Uyk8NTyE2CHJs9KWTp
</commit_message>
<xml_diff>
--- a/output/AI활용_취업포트폴리오_강의계획서_1장.pptx
+++ b/output/AI활용_취업포트폴리오_강의계획서_1장.pptx
@@ -3097,7 +3097,7 @@
         <p:spPr>
           <a:xfrm>
             <a:off x="0" y="0"/>
-            <a:ext cx="12192000" cy="1206500"/>
+            <a:ext cx="12192000" cy="1270000"/>
           </a:xfrm>
           <a:prstGeom prst="rect">
             <a:avLst/>
@@ -3140,14 +3140,14 @@
         </p:nvSpPr>
         <p:spPr>
           <a:xfrm>
-            <a:off x="0" y="1206500"/>
+            <a:off x="0" y="1270000"/>
             <a:ext cx="12192000" cy="38100"/>
           </a:xfrm>
           <a:prstGeom prst="rect">
             <a:avLst/>
           </a:prstGeom>
           <a:solidFill>
-            <a:srgbClr val="10A37F"/>
+            <a:srgbClr val="0E9F7A"/>
           </a:solidFill>
           <a:ln>
             <a:noFill/>
@@ -3184,8 +3184,8 @@
         </p:nvSpPr>
         <p:spPr>
           <a:xfrm>
-            <a:off x="381000" y="177800"/>
-            <a:ext cx="8255000" cy="254000"/>
+            <a:off x="508000" y="228600"/>
+            <a:ext cx="8255000" cy="190500"/>
           </a:xfrm>
           <a:prstGeom prst="rect">
             <a:avLst/>
@@ -3193,11 +3193,16 @@
           <a:noFill/>
         </p:spPr>
         <p:txBody>
-          <a:bodyPr wrap="square" lIns="25400" rIns="25400" tIns="12700" bIns="12700">
-            <a:spAutoFit/>
+          <a:bodyPr wrap="square" anchor="t" lIns="0" rIns="0" tIns="0" bIns="0">
+            <a:noAutofit/>
           </a:bodyPr>
           <a:lstStyle/>
           <a:p>
+            <a:pPr algn="l">
+              <a:lnSpc>
+                <a:spcPct val="115000"/>
+              </a:lnSpc>
+            </a:pPr>
             <a:r>
               <a:rPr sz="1300" b="1">
                 <a:solidFill>
@@ -3205,7 +3210,7 @@
                 </a:solidFill>
                 <a:latin typeface="Pretendard"/>
               </a:rPr>
-              <a:t>강의계획서 · 총 16시간 (2회기 × 8시간)</a:t>
+              <a:t>강의계획서  ·  총 16시간 (2회기 × 8시간)</a:t>
             </a:r>
           </a:p>
         </p:txBody>
@@ -3218,8 +3223,8 @@
         </p:nvSpPr>
         <p:spPr>
           <a:xfrm>
-            <a:off x="381000" y="330200"/>
-            <a:ext cx="8890000" cy="444500"/>
+            <a:off x="508000" y="419100"/>
+            <a:ext cx="8255000" cy="381000"/>
           </a:xfrm>
           <a:prstGeom prst="rect">
             <a:avLst/>
@@ -3227,13 +3232,18 @@
           <a:noFill/>
         </p:spPr>
         <p:txBody>
-          <a:bodyPr wrap="square" lIns="25400" rIns="25400" tIns="12700" bIns="12700">
-            <a:spAutoFit/>
+          <a:bodyPr wrap="square" anchor="t" lIns="0" rIns="0" tIns="0" bIns="0">
+            <a:noAutofit/>
           </a:bodyPr>
           <a:lstStyle/>
           <a:p>
-            <a:r>
-              <a:rPr sz="3000" b="1">
+            <a:pPr algn="l">
+              <a:lnSpc>
+                <a:spcPct val="115000"/>
+              </a:lnSpc>
+            </a:pPr>
+            <a:r>
+              <a:rPr sz="3200" b="1">
                 <a:solidFill>
                   <a:srgbClr val="FFFFFF"/>
                 </a:solidFill>
@@ -3252,8 +3262,8 @@
         </p:nvSpPr>
         <p:spPr>
           <a:xfrm>
-            <a:off x="381000" y="857250"/>
-            <a:ext cx="9525000" cy="254000"/>
+            <a:off x="508000" y="939800"/>
+            <a:ext cx="8255000" cy="190500"/>
           </a:xfrm>
           <a:prstGeom prst="rect">
             <a:avLst/>
@@ -3261,11 +3271,16 @@
           <a:noFill/>
         </p:spPr>
         <p:txBody>
-          <a:bodyPr wrap="square" lIns="25400" rIns="25400" tIns="12700" bIns="12700">
-            <a:spAutoFit/>
+          <a:bodyPr wrap="square" anchor="t" lIns="0" rIns="0" tIns="0" bIns="0">
+            <a:noAutofit/>
           </a:bodyPr>
           <a:lstStyle/>
           <a:p>
+            <a:pPr algn="l">
+              <a:lnSpc>
+                <a:spcPct val="115000"/>
+              </a:lnSpc>
+            </a:pPr>
             <a:r>
               <a:rPr sz="1400" b="0">
                 <a:solidFill>
@@ -3273,7 +3288,7 @@
                 </a:solidFill>
                 <a:latin typeface="Pretendard"/>
               </a:rPr>
-              <a:t>AI·Data·CV 직무 지원자를 위한 기술이력서와 포트폴리오 면접 실습</a:t>
+              <a:t>AI·Data·CV 직무 지원자를 위한 기술이력서·포트폴리오·면접 실습</a:t>
             </a:r>
           </a:p>
         </p:txBody>
@@ -3286,8 +3301,8 @@
         </p:nvSpPr>
         <p:spPr>
           <a:xfrm>
-            <a:off x="9207500" y="444500"/>
-            <a:ext cx="2667000" cy="508000"/>
+            <a:off x="8255000" y="571500"/>
+            <a:ext cx="3429000" cy="444500"/>
           </a:xfrm>
           <a:prstGeom prst="rect">
             <a:avLst/>
@@ -3295,14 +3310,18 @@
           <a:noFill/>
         </p:spPr>
         <p:txBody>
-          <a:bodyPr wrap="square" lIns="25400" rIns="25400" tIns="12700" bIns="12700">
-            <a:spAutoFit/>
+          <a:bodyPr wrap="square" anchor="t" lIns="0" rIns="0" tIns="0" bIns="0">
+            <a:noAutofit/>
           </a:bodyPr>
           <a:lstStyle/>
           <a:p>
-            <a:pPr algn="r"/>
-            <a:r>
-              <a:rPr sz="1400" b="1">
+            <a:pPr algn="r">
+              <a:lnSpc>
+                <a:spcPct val="115000"/>
+              </a:lnSpc>
+            </a:pPr>
+            <a:r>
+              <a:rPr sz="1500" b="1">
                 <a:solidFill>
                   <a:srgbClr val="FFFFFF"/>
                 </a:solidFill>
@@ -3312,7 +3331,11 @@
             </a:r>
           </a:p>
           <a:p>
-            <a:pPr algn="r"/>
+            <a:pPr algn="r">
+              <a:lnSpc>
+                <a:spcPct val="115000"/>
+              </a:lnSpc>
+            </a:pPr>
             <a:r>
               <a:rPr sz="1200" b="0">
                 <a:solidFill>
@@ -3327,23 +3350,229 @@
       </p:sp>
       <p:sp>
         <p:nvSpPr>
-          <p:cNvPr id="8" name="Rectangle 7"/>
+          <p:cNvPr id="8" name="TextBox 7"/>
+          <p:cNvSpPr txBox="1"/>
+          <p:nvPr/>
+        </p:nvSpPr>
+        <p:spPr>
+          <a:xfrm>
+            <a:off x="508000" y="1498600"/>
+            <a:ext cx="889000" cy="190500"/>
+          </a:xfrm>
+          <a:prstGeom prst="rect">
+            <a:avLst/>
+          </a:prstGeom>
+          <a:noFill/>
+        </p:spPr>
+        <p:txBody>
+          <a:bodyPr wrap="square" anchor="t" lIns="0" rIns="0" tIns="0" bIns="0">
+            <a:noAutofit/>
+          </a:bodyPr>
+          <a:lstStyle/>
+          <a:p>
+            <a:pPr algn="l">
+              <a:lnSpc>
+                <a:spcPct val="115000"/>
+              </a:lnSpc>
+            </a:pPr>
+            <a:r>
+              <a:rPr sz="1300" b="1">
+                <a:solidFill>
+                  <a:srgbClr val="0E9F7A"/>
+                </a:solidFill>
+                <a:latin typeface="Pretendard"/>
+              </a:rPr>
+              <a:t>대상</a:t>
+            </a:r>
+          </a:p>
+        </p:txBody>
+      </p:sp>
+      <p:sp>
+        <p:nvSpPr>
+          <p:cNvPr id="9" name="TextBox 8"/>
+          <p:cNvSpPr txBox="1"/>
+          <p:nvPr/>
+        </p:nvSpPr>
+        <p:spPr>
+          <a:xfrm>
+            <a:off x="1206500" y="1498600"/>
+            <a:ext cx="10795000" cy="190500"/>
+          </a:xfrm>
+          <a:prstGeom prst="rect">
+            <a:avLst/>
+          </a:prstGeom>
+          <a:noFill/>
+        </p:spPr>
+        <p:txBody>
+          <a:bodyPr wrap="square" anchor="t" lIns="0" rIns="0" tIns="0" bIns="0">
+            <a:noAutofit/>
+          </a:bodyPr>
+          <a:lstStyle/>
+          <a:p>
+            <a:pPr algn="l">
+              <a:lnSpc>
+                <a:spcPct val="115000"/>
+              </a:lnSpc>
+            </a:pPr>
+            <a:r>
+              <a:rPr sz="1300" b="0">
+                <a:solidFill>
+                  <a:srgbClr val="141A3C"/>
+                </a:solidFill>
+                <a:latin typeface="Pretendard"/>
+              </a:rPr>
+              <a:t>AI·Data·CV 프로젝트 경험이 있는 취업 준비생</a:t>
+            </a:r>
+          </a:p>
+        </p:txBody>
+      </p:sp>
+      <p:sp>
+        <p:nvSpPr>
+          <p:cNvPr id="10" name="TextBox 9"/>
+          <p:cNvSpPr txBox="1"/>
+          <p:nvPr/>
+        </p:nvSpPr>
+        <p:spPr>
+          <a:xfrm>
+            <a:off x="508000" y="1739900"/>
+            <a:ext cx="889000" cy="190500"/>
+          </a:xfrm>
+          <a:prstGeom prst="rect">
+            <a:avLst/>
+          </a:prstGeom>
+          <a:noFill/>
+        </p:spPr>
+        <p:txBody>
+          <a:bodyPr wrap="square" anchor="t" lIns="0" rIns="0" tIns="0" bIns="0">
+            <a:noAutofit/>
+          </a:bodyPr>
+          <a:lstStyle/>
+          <a:p>
+            <a:pPr algn="l">
+              <a:lnSpc>
+                <a:spcPct val="115000"/>
+              </a:lnSpc>
+            </a:pPr>
+            <a:r>
+              <a:rPr sz="1300" b="1">
+                <a:solidFill>
+                  <a:srgbClr val="0E9F7A"/>
+                </a:solidFill>
+                <a:latin typeface="Pretendard"/>
+              </a:rPr>
+              <a:t>목표</a:t>
+            </a:r>
+          </a:p>
+        </p:txBody>
+      </p:sp>
+      <p:sp>
+        <p:nvSpPr>
+          <p:cNvPr id="11" name="TextBox 10"/>
+          <p:cNvSpPr txBox="1"/>
+          <p:nvPr/>
+        </p:nvSpPr>
+        <p:spPr>
+          <a:xfrm>
+            <a:off x="1206500" y="1739900"/>
+            <a:ext cx="10795000" cy="190500"/>
+          </a:xfrm>
+          <a:prstGeom prst="rect">
+            <a:avLst/>
+          </a:prstGeom>
+          <a:noFill/>
+        </p:spPr>
+        <p:txBody>
+          <a:bodyPr wrap="square" anchor="t" lIns="0" rIns="0" tIns="0" bIns="0">
+            <a:noAutofit/>
+          </a:bodyPr>
+          <a:lstStyle/>
+          <a:p>
+            <a:pPr algn="l">
+              <a:lnSpc>
+                <a:spcPct val="115000"/>
+              </a:lnSpc>
+            </a:pPr>
+            <a:r>
+              <a:rPr sz="1300" b="0">
+                <a:solidFill>
+                  <a:srgbClr val="141A3C"/>
+                </a:solidFill>
+                <a:latin typeface="Pretendard"/>
+              </a:rPr>
+              <a:t>AI로 돕고 본인이 근거를 검증해, 프로젝트 1개의 채용 문서와 면접 답변을 완성</a:t>
+            </a:r>
+          </a:p>
+        </p:txBody>
+      </p:sp>
+      <p:sp>
+        <p:nvSpPr>
+          <p:cNvPr id="12" name="TextBox 11"/>
+          <p:cNvSpPr txBox="1"/>
+          <p:nvPr/>
+        </p:nvSpPr>
+        <p:spPr>
+          <a:xfrm>
+            <a:off x="508000" y="2095500"/>
+            <a:ext cx="5461000" cy="190500"/>
+          </a:xfrm>
+          <a:prstGeom prst="rect">
+            <a:avLst/>
+          </a:prstGeom>
+          <a:noFill/>
+        </p:spPr>
+        <p:txBody>
+          <a:bodyPr wrap="square" anchor="t" lIns="0" rIns="0" tIns="0" bIns="0">
+            <a:noAutofit/>
+          </a:bodyPr>
+          <a:lstStyle/>
+          <a:p>
+            <a:pPr algn="l">
+              <a:lnSpc>
+                <a:spcPct val="115000"/>
+              </a:lnSpc>
+            </a:pPr>
+            <a:r>
+              <a:rPr sz="1500" b="1">
+                <a:solidFill>
+                  <a:srgbClr val="0E9F7A"/>
+                </a:solidFill>
+                <a:latin typeface="Pretendard"/>
+              </a:rPr>
+              <a:t>1회기  이력서 · 자기소개서</a:t>
+            </a:r>
+            <a:r>
+              <a:rPr sz="1100" b="0">
+                <a:solidFill>
+                  <a:srgbClr val="8A90A8"/>
+                </a:solidFill>
+                <a:latin typeface="Pretendard"/>
+              </a:rPr>
+              <a:t>   8시간 · 2시간 × 4모듈</a:t>
+            </a:r>
+          </a:p>
+        </p:txBody>
+      </p:sp>
+      <p:sp>
+        <p:nvSpPr>
+          <p:cNvPr id="13" name="Rectangle 12"/>
           <p:cNvSpPr/>
           <p:nvPr/>
         </p:nvSpPr>
         <p:spPr>
           <a:xfrm>
-            <a:off x="381000" y="1397000"/>
-            <a:ext cx="11430000" cy="635000"/>
+            <a:off x="508000" y="2387600"/>
+            <a:ext cx="5461000" cy="457200"/>
           </a:xfrm>
           <a:prstGeom prst="rect">
             <a:avLst/>
           </a:prstGeom>
           <a:solidFill>
-            <a:srgbClr val="F3F5FA"/>
+            <a:srgbClr val="FFFFFF"/>
           </a:solidFill>
-          <a:ln>
-            <a:noFill/>
+          <a:ln w="9525">
+            <a:solidFill>
+              <a:srgbClr val="DDE1EE"/>
+            </a:solidFill>
           </a:ln>
           <a:effectLst/>
         </p:spPr>
@@ -3371,145 +3600,23 @@
       </p:sp>
       <p:sp>
         <p:nvSpPr>
-          <p:cNvPr id="9" name="TextBox 8"/>
-          <p:cNvSpPr txBox="1"/>
-          <p:nvPr/>
-        </p:nvSpPr>
-        <p:spPr>
-          <a:xfrm>
-            <a:off x="508000" y="1460500"/>
-            <a:ext cx="3556000" cy="508000"/>
-          </a:xfrm>
-          <a:prstGeom prst="rect">
-            <a:avLst/>
-          </a:prstGeom>
-          <a:noFill/>
-        </p:spPr>
-        <p:txBody>
-          <a:bodyPr wrap="square" lIns="25400" rIns="25400" tIns="12700" bIns="12700" anchor="ctr">
-            <a:spAutoFit/>
-          </a:bodyPr>
-          <a:lstStyle/>
-          <a:p>
-            <a:r>
-              <a:rPr sz="1200" b="1">
-                <a:solidFill>
-                  <a:srgbClr val="10A37F"/>
-                </a:solidFill>
-                <a:latin typeface="Pretendard"/>
-              </a:rPr>
-              <a:t>대상  </a:t>
-            </a:r>
-            <a:r>
-              <a:rPr sz="1200" b="0">
-                <a:solidFill>
-                  <a:srgbClr val="4A5070"/>
-                </a:solidFill>
-                <a:latin typeface="Pretendard"/>
-              </a:rPr>
-              <a:t>AI·Data·CV 프로젝트 경험이 있는 취업 준비생</a:t>
-            </a:r>
-          </a:p>
-        </p:txBody>
-      </p:sp>
-      <p:sp>
-        <p:nvSpPr>
-          <p:cNvPr id="10" name="TextBox 9"/>
-          <p:cNvSpPr txBox="1"/>
-          <p:nvPr/>
-        </p:nvSpPr>
-        <p:spPr>
-          <a:xfrm>
-            <a:off x="4064000" y="1460500"/>
-            <a:ext cx="7620000" cy="508000"/>
-          </a:xfrm>
-          <a:prstGeom prst="rect">
-            <a:avLst/>
-          </a:prstGeom>
-          <a:noFill/>
-        </p:spPr>
-        <p:txBody>
-          <a:bodyPr wrap="square" lIns="25400" rIns="25400" tIns="12700" bIns="12700" anchor="ctr">
-            <a:spAutoFit/>
-          </a:bodyPr>
-          <a:lstStyle/>
-          <a:p>
-            <a:r>
-              <a:rPr sz="1200" b="1">
-                <a:solidFill>
-                  <a:srgbClr val="10A37F"/>
-                </a:solidFill>
-                <a:latin typeface="Pretendard"/>
-              </a:rPr>
-              <a:t>목표  </a:t>
-            </a:r>
-            <a:r>
-              <a:rPr sz="1200" b="0">
-                <a:solidFill>
-                  <a:srgbClr val="4A5070"/>
-                </a:solidFill>
-                <a:latin typeface="Pretendard"/>
-              </a:rPr>
-              <a:t>AI로 경험 분석·문서 작성·면접 연습을 돕고, 본인이 근거를 검증하여 프로젝트 1개의 채용 문서와 답변을 개선 (회기별 피드백 후 수정본 완성)</a:t>
-            </a:r>
-          </a:p>
-        </p:txBody>
-      </p:sp>
-      <p:sp>
-        <p:nvSpPr>
-          <p:cNvPr id="11" name="TextBox 10"/>
-          <p:cNvSpPr txBox="1"/>
-          <p:nvPr/>
-        </p:nvSpPr>
-        <p:spPr>
-          <a:xfrm>
-            <a:off x="381000" y="2190750"/>
-            <a:ext cx="5651500" cy="228600"/>
-          </a:xfrm>
-          <a:prstGeom prst="rect">
-            <a:avLst/>
-          </a:prstGeom>
-          <a:noFill/>
-        </p:spPr>
-        <p:txBody>
-          <a:bodyPr wrap="square" lIns="25400" rIns="25400" tIns="12700" bIns="12700">
-            <a:spAutoFit/>
-          </a:bodyPr>
-          <a:lstStyle/>
-          <a:p>
-            <a:r>
-              <a:rPr sz="1400" b="1">
-                <a:solidFill>
-                  <a:srgbClr val="10A37F"/>
-                </a:solidFill>
-                <a:latin typeface="Pretendard"/>
-              </a:rPr>
-              <a:t>1회기 · 이력서·자기소개서 (8시간)</a:t>
-            </a:r>
-          </a:p>
-        </p:txBody>
-      </p:sp>
-      <p:sp>
-        <p:nvSpPr>
-          <p:cNvPr id="12" name="Rectangle 11"/>
+          <p:cNvPr id="14" name="Oval 13"/>
           <p:cNvSpPr/>
           <p:nvPr/>
         </p:nvSpPr>
         <p:spPr>
           <a:xfrm>
-            <a:off x="381000" y="2457450"/>
-            <a:ext cx="5651500" cy="635000"/>
-          </a:xfrm>
-          <a:prstGeom prst="rect">
+            <a:off x="635000" y="2476500"/>
+            <a:ext cx="279400" cy="279400"/>
+          </a:xfrm>
+          <a:prstGeom prst="ellipse">
             <a:avLst/>
           </a:prstGeom>
           <a:solidFill>
-            <a:srgbClr val="FFFFFF"/>
+            <a:srgbClr val="0E9F7A"/>
           </a:solidFill>
-          <a:ln w="9525">
-            <a:solidFill>
-              <a:srgbClr val="DDE1EE"/>
-            </a:solidFill>
+          <a:ln>
+            <a:noFill/>
           </a:ln>
           <a:effectLst/>
         </p:spPr>
@@ -3537,23 +3644,142 @@
       </p:sp>
       <p:sp>
         <p:nvSpPr>
-          <p:cNvPr id="13" name="Rectangle 12"/>
+          <p:cNvPr id="15" name="TextBox 14"/>
+          <p:cNvSpPr txBox="1"/>
+          <p:nvPr/>
+        </p:nvSpPr>
+        <p:spPr>
+          <a:xfrm>
+            <a:off x="635000" y="2476500"/>
+            <a:ext cx="279400" cy="279400"/>
+          </a:xfrm>
+          <a:prstGeom prst="rect">
+            <a:avLst/>
+          </a:prstGeom>
+          <a:noFill/>
+        </p:spPr>
+        <p:txBody>
+          <a:bodyPr wrap="square" anchor="ctr" lIns="0" rIns="0" tIns="0" bIns="0">
+            <a:noAutofit/>
+          </a:bodyPr>
+          <a:lstStyle/>
+          <a:p>
+            <a:pPr algn="ctr">
+              <a:lnSpc>
+                <a:spcPct val="100000"/>
+              </a:lnSpc>
+            </a:pPr>
+            <a:r>
+              <a:rPr sz="1500" b="1">
+                <a:solidFill>
+                  <a:srgbClr val="FFFFFF"/>
+                </a:solidFill>
+                <a:latin typeface="Pretendard"/>
+              </a:rPr>
+              <a:t>①</a:t>
+            </a:r>
+          </a:p>
+        </p:txBody>
+      </p:sp>
+      <p:sp>
+        <p:nvSpPr>
+          <p:cNvPr id="16" name="TextBox 15"/>
+          <p:cNvSpPr txBox="1"/>
+          <p:nvPr/>
+        </p:nvSpPr>
+        <p:spPr>
+          <a:xfrm>
+            <a:off x="1041400" y="2387600"/>
+            <a:ext cx="2540000" cy="457200"/>
+          </a:xfrm>
+          <a:prstGeom prst="rect">
+            <a:avLst/>
+          </a:prstGeom>
+          <a:noFill/>
+        </p:spPr>
+        <p:txBody>
+          <a:bodyPr wrap="square" anchor="ctr" lIns="0" rIns="0" tIns="0" bIns="0">
+            <a:noAutofit/>
+          </a:bodyPr>
+          <a:lstStyle/>
+          <a:p>
+            <a:pPr algn="l">
+              <a:lnSpc>
+                <a:spcPct val="100000"/>
+              </a:lnSpc>
+            </a:pPr>
+            <a:r>
+              <a:rPr sz="1500" b="1">
+                <a:solidFill>
+                  <a:srgbClr val="141A3C"/>
+                </a:solidFill>
+                <a:latin typeface="Pretendard"/>
+              </a:rPr>
+              <a:t>채용공고 분석</a:t>
+            </a:r>
+          </a:p>
+        </p:txBody>
+      </p:sp>
+      <p:sp>
+        <p:nvSpPr>
+          <p:cNvPr id="17" name="TextBox 16"/>
+          <p:cNvSpPr txBox="1"/>
+          <p:nvPr/>
+        </p:nvSpPr>
+        <p:spPr>
+          <a:xfrm>
+            <a:off x="3619500" y="2387600"/>
+            <a:ext cx="2286000" cy="457200"/>
+          </a:xfrm>
+          <a:prstGeom prst="rect">
+            <a:avLst/>
+          </a:prstGeom>
+          <a:noFill/>
+        </p:spPr>
+        <p:txBody>
+          <a:bodyPr wrap="square" anchor="ctr" lIns="0" rIns="0" tIns="0" bIns="0">
+            <a:noAutofit/>
+          </a:bodyPr>
+          <a:lstStyle/>
+          <a:p>
+            <a:pPr algn="l">
+              <a:lnSpc>
+                <a:spcPct val="100000"/>
+              </a:lnSpc>
+            </a:pPr>
+            <a:r>
+              <a:rPr sz="1250" b="1">
+                <a:solidFill>
+                  <a:srgbClr val="0E9F7A"/>
+                </a:solidFill>
+                <a:latin typeface="Pretendard"/>
+              </a:rPr>
+              <a:t>직무 분석표</a:t>
+            </a:r>
+          </a:p>
+        </p:txBody>
+      </p:sp>
+      <p:sp>
+        <p:nvSpPr>
+          <p:cNvPr id="18" name="Rectangle 17"/>
           <p:cNvSpPr/>
           <p:nvPr/>
         </p:nvSpPr>
         <p:spPr>
           <a:xfrm>
-            <a:off x="381000" y="2457450"/>
-            <a:ext cx="50800" cy="635000"/>
+            <a:off x="508000" y="2921000"/>
+            <a:ext cx="5461000" cy="457200"/>
           </a:xfrm>
           <a:prstGeom prst="rect">
             <a:avLst/>
           </a:prstGeom>
           <a:solidFill>
-            <a:srgbClr val="10A37F"/>
+            <a:srgbClr val="FFFFFF"/>
           </a:solidFill>
-          <a:ln>
-            <a:noFill/>
+          <a:ln w="9525">
+            <a:solidFill>
+              <a:srgbClr val="DDE1EE"/>
+            </a:solidFill>
           </a:ln>
           <a:effectLst/>
         </p:spPr>
@@ -3581,99 +3807,20 @@
       </p:sp>
       <p:sp>
         <p:nvSpPr>
-          <p:cNvPr id="14" name="TextBox 13"/>
-          <p:cNvSpPr txBox="1"/>
-          <p:nvPr/>
-        </p:nvSpPr>
-        <p:spPr>
-          <a:xfrm>
-            <a:off x="508000" y="2508250"/>
-            <a:ext cx="825500" cy="571500"/>
-          </a:xfrm>
-          <a:prstGeom prst="rect">
-            <a:avLst/>
-          </a:prstGeom>
-          <a:noFill/>
-        </p:spPr>
-        <p:txBody>
-          <a:bodyPr wrap="square" lIns="25400" rIns="25400" tIns="12700" bIns="12700" anchor="ctr">
-            <a:spAutoFit/>
-          </a:bodyPr>
-          <a:lstStyle/>
-          <a:p>
-            <a:r>
-              <a:rPr sz="1300" b="1">
-                <a:solidFill>
-                  <a:srgbClr val="141A3C"/>
-                </a:solidFill>
-                <a:latin typeface="Pretendard"/>
-              </a:rPr>
-              <a:t>1회기 ①</a:t>
-            </a:r>
-          </a:p>
-          <a:p>
-            <a:r>
-              <a:rPr sz="1100" b="0">
-                <a:solidFill>
-                  <a:srgbClr val="4A5070"/>
-                </a:solidFill>
-                <a:latin typeface="Pretendard"/>
-              </a:rPr>
-              <a:t>2시간</a:t>
-            </a:r>
-          </a:p>
-        </p:txBody>
-      </p:sp>
-      <p:sp>
-        <p:nvSpPr>
-          <p:cNvPr id="15" name="TextBox 14"/>
-          <p:cNvSpPr txBox="1"/>
-          <p:nvPr/>
-        </p:nvSpPr>
-        <p:spPr>
-          <a:xfrm>
-            <a:off x="1333500" y="2508250"/>
-            <a:ext cx="2984500" cy="584200"/>
-          </a:xfrm>
-          <a:prstGeom prst="rect">
-            <a:avLst/>
-          </a:prstGeom>
-          <a:noFill/>
-        </p:spPr>
-        <p:txBody>
-          <a:bodyPr wrap="square" lIns="25400" rIns="25400" tIns="12700" bIns="12700" anchor="ctr">
-            <a:spAutoFit/>
-          </a:bodyPr>
-          <a:lstStyle/>
-          <a:p>
-            <a:r>
-              <a:rPr sz="1100" b="0">
-                <a:solidFill>
-                  <a:srgbClr val="4A5070"/>
-                </a:solidFill>
-                <a:latin typeface="Pretendard"/>
-              </a:rPr>
-              <a:t>AI로 채용공고의 요구 역량 추출·분류. 공고 원문과 대조하고 목표 직무와 준비 범위 확정.</a:t>
-            </a:r>
-          </a:p>
-        </p:txBody>
-      </p:sp>
-      <p:sp>
-        <p:nvSpPr>
-          <p:cNvPr id="16" name="Rectangle 15"/>
+          <p:cNvPr id="19" name="Oval 18"/>
           <p:cNvSpPr/>
           <p:nvPr/>
         </p:nvSpPr>
         <p:spPr>
           <a:xfrm>
-            <a:off x="4381500" y="2520950"/>
-            <a:ext cx="1555750" cy="508000"/>
-          </a:xfrm>
-          <a:prstGeom prst="rect">
+            <a:off x="635000" y="3009900"/>
+            <a:ext cx="279400" cy="279400"/>
+          </a:xfrm>
+          <a:prstGeom prst="ellipse">
             <a:avLst/>
           </a:prstGeom>
           <a:solidFill>
-            <a:srgbClr val="F3F5FA"/>
+            <a:srgbClr val="0E9F7A"/>
           </a:solidFill>
           <a:ln>
             <a:noFill/>
@@ -3704,14 +3851,14 @@
       </p:sp>
       <p:sp>
         <p:nvSpPr>
-          <p:cNvPr id="17" name="TextBox 16"/>
+          <p:cNvPr id="20" name="TextBox 19"/>
           <p:cNvSpPr txBox="1"/>
           <p:nvPr/>
         </p:nvSpPr>
         <p:spPr>
           <a:xfrm>
-            <a:off x="4419600" y="2520950"/>
-            <a:ext cx="1492250" cy="508000"/>
+            <a:off x="635000" y="3009900"/>
+            <a:ext cx="279400" cy="279400"/>
           </a:xfrm>
           <a:prstGeom prst="rect">
             <a:avLst/>
@@ -3719,44 +3866,135 @@
           <a:noFill/>
         </p:spPr>
         <p:txBody>
-          <a:bodyPr wrap="square" lIns="25400" rIns="25400" tIns="12700" bIns="12700" anchor="ctr">
-            <a:spAutoFit/>
+          <a:bodyPr wrap="square" anchor="ctr" lIns="0" rIns="0" tIns="0" bIns="0">
+            <a:noAutofit/>
           </a:bodyPr>
           <a:lstStyle/>
           <a:p>
-            <a:r>
-              <a:rPr sz="900" b="1">
-                <a:solidFill>
-                  <a:srgbClr val="10A37F"/>
-                </a:solidFill>
-                <a:latin typeface="Pretendard"/>
-              </a:rPr>
-              <a:t>산출물</a:t>
-            </a:r>
-          </a:p>
-          <a:p>
-            <a:r>
-              <a:rPr sz="1100" b="1">
+            <a:pPr algn="ctr">
+              <a:lnSpc>
+                <a:spcPct val="100000"/>
+              </a:lnSpc>
+            </a:pPr>
+            <a:r>
+              <a:rPr sz="1500" b="1">
+                <a:solidFill>
+                  <a:srgbClr val="FFFFFF"/>
+                </a:solidFill>
+                <a:latin typeface="Pretendard"/>
+              </a:rPr>
+              <a:t>②</a:t>
+            </a:r>
+          </a:p>
+        </p:txBody>
+      </p:sp>
+      <p:sp>
+        <p:nvSpPr>
+          <p:cNvPr id="21" name="TextBox 20"/>
+          <p:cNvSpPr txBox="1"/>
+          <p:nvPr/>
+        </p:nvSpPr>
+        <p:spPr>
+          <a:xfrm>
+            <a:off x="1041400" y="2921000"/>
+            <a:ext cx="2540000" cy="457200"/>
+          </a:xfrm>
+          <a:prstGeom prst="rect">
+            <a:avLst/>
+          </a:prstGeom>
+          <a:noFill/>
+        </p:spPr>
+        <p:txBody>
+          <a:bodyPr wrap="square" anchor="ctr" lIns="0" rIns="0" tIns="0" bIns="0">
+            <a:noAutofit/>
+          </a:bodyPr>
+          <a:lstStyle/>
+          <a:p>
+            <a:pPr algn="l">
+              <a:lnSpc>
+                <a:spcPct val="100000"/>
+              </a:lnSpc>
+            </a:pPr>
+            <a:r>
+              <a:rPr sz="1500" b="1">
                 <a:solidFill>
                   <a:srgbClr val="141A3C"/>
                 </a:solidFill>
                 <a:latin typeface="Pretendard"/>
               </a:rPr>
-              <a:t>직무 분석표 1개</a:t>
-            </a:r>
-          </a:p>
-        </p:txBody>
-      </p:sp>
-      <p:sp>
-        <p:nvSpPr>
-          <p:cNvPr id="18" name="Rectangle 17"/>
+              <a:t>경험 탐색·구조화</a:t>
+            </a:r>
+            <a:r>
+              <a:rPr sz="1200" b="0">
+                <a:solidFill>
+                  <a:srgbClr val="4A5070"/>
+                </a:solidFill>
+                <a:latin typeface="Pretendard"/>
+              </a:rPr>
+              <a:t>   </a:t>
+            </a:r>
+            <a:r>
+              <a:rPr sz="1100" b="1" u="sng">
+                <a:solidFill>
+                  <a:srgbClr val="0E9F7A"/>
+                </a:solidFill>
+                <a:latin typeface="Pretendard"/>
+                <a:hlinkClick r:id="rId2"/>
+              </a:rPr>
+              <a:t>도구 1</a:t>
+            </a:r>
+          </a:p>
+        </p:txBody>
+      </p:sp>
+      <p:sp>
+        <p:nvSpPr>
+          <p:cNvPr id="22" name="TextBox 21"/>
+          <p:cNvSpPr txBox="1"/>
+          <p:nvPr/>
+        </p:nvSpPr>
+        <p:spPr>
+          <a:xfrm>
+            <a:off x="3619500" y="2921000"/>
+            <a:ext cx="2286000" cy="457200"/>
+          </a:xfrm>
+          <a:prstGeom prst="rect">
+            <a:avLst/>
+          </a:prstGeom>
+          <a:noFill/>
+        </p:spPr>
+        <p:txBody>
+          <a:bodyPr wrap="square" anchor="ctr" lIns="0" rIns="0" tIns="0" bIns="0">
+            <a:noAutofit/>
+          </a:bodyPr>
+          <a:lstStyle/>
+          <a:p>
+            <a:pPr algn="l">
+              <a:lnSpc>
+                <a:spcPct val="100000"/>
+              </a:lnSpc>
+            </a:pPr>
+            <a:r>
+              <a:rPr sz="1250" b="1">
+                <a:solidFill>
+                  <a:srgbClr val="0E9F7A"/>
+                </a:solidFill>
+                <a:latin typeface="Pretendard"/>
+              </a:rPr>
+              <a:t>경험카드 · 근거 목록</a:t>
+            </a:r>
+          </a:p>
+        </p:txBody>
+      </p:sp>
+      <p:sp>
+        <p:nvSpPr>
+          <p:cNvPr id="23" name="Rectangle 22"/>
           <p:cNvSpPr/>
           <p:nvPr/>
         </p:nvSpPr>
         <p:spPr>
           <a:xfrm>
-            <a:off x="381000" y="3155950"/>
-            <a:ext cx="5651500" cy="635000"/>
+            <a:off x="508000" y="3454400"/>
+            <a:ext cx="5461000" cy="457200"/>
           </a:xfrm>
           <a:prstGeom prst="rect">
             <a:avLst/>
@@ -3795,20 +4033,20 @@
       </p:sp>
       <p:sp>
         <p:nvSpPr>
-          <p:cNvPr id="19" name="Rectangle 18"/>
+          <p:cNvPr id="24" name="Oval 23"/>
           <p:cNvSpPr/>
           <p:nvPr/>
         </p:nvSpPr>
         <p:spPr>
           <a:xfrm>
-            <a:off x="381000" y="3155950"/>
-            <a:ext cx="50800" cy="635000"/>
-          </a:xfrm>
-          <a:prstGeom prst="rect">
+            <a:off x="635000" y="3543300"/>
+            <a:ext cx="279400" cy="279400"/>
+          </a:xfrm>
+          <a:prstGeom prst="ellipse">
             <a:avLst/>
           </a:prstGeom>
           <a:solidFill>
-            <a:srgbClr val="10A37F"/>
+            <a:srgbClr val="0E9F7A"/>
           </a:solidFill>
           <a:ln>
             <a:noFill/>
@@ -3839,14 +4077,14 @@
       </p:sp>
       <p:sp>
         <p:nvSpPr>
-          <p:cNvPr id="20" name="TextBox 19"/>
+          <p:cNvPr id="25" name="TextBox 24"/>
           <p:cNvSpPr txBox="1"/>
           <p:nvPr/>
         </p:nvSpPr>
         <p:spPr>
           <a:xfrm>
-            <a:off x="508000" y="3206750"/>
-            <a:ext cx="825500" cy="571500"/>
+            <a:off x="635000" y="3543300"/>
+            <a:ext cx="279400" cy="279400"/>
           </a:xfrm>
           <a:prstGeom prst="rect">
             <a:avLst/>
@@ -3854,44 +4092,38 @@
           <a:noFill/>
         </p:spPr>
         <p:txBody>
-          <a:bodyPr wrap="square" lIns="25400" rIns="25400" tIns="12700" bIns="12700" anchor="ctr">
-            <a:spAutoFit/>
+          <a:bodyPr wrap="square" anchor="ctr" lIns="0" rIns="0" tIns="0" bIns="0">
+            <a:noAutofit/>
           </a:bodyPr>
           <a:lstStyle/>
           <a:p>
-            <a:r>
-              <a:rPr sz="1300" b="1">
-                <a:solidFill>
-                  <a:srgbClr val="141A3C"/>
-                </a:solidFill>
-                <a:latin typeface="Pretendard"/>
-              </a:rPr>
-              <a:t>1회기 ②</a:t>
-            </a:r>
-          </a:p>
-          <a:p>
-            <a:r>
-              <a:rPr sz="1100" b="0">
-                <a:solidFill>
-                  <a:srgbClr val="4A5070"/>
-                </a:solidFill>
-                <a:latin typeface="Pretendard"/>
-              </a:rPr>
-              <a:t>2시간</a:t>
-            </a:r>
-          </a:p>
-        </p:txBody>
-      </p:sp>
-      <p:sp>
-        <p:nvSpPr>
-          <p:cNvPr id="21" name="TextBox 20"/>
+            <a:pPr algn="ctr">
+              <a:lnSpc>
+                <a:spcPct val="100000"/>
+              </a:lnSpc>
+            </a:pPr>
+            <a:r>
+              <a:rPr sz="1500" b="1">
+                <a:solidFill>
+                  <a:srgbClr val="FFFFFF"/>
+                </a:solidFill>
+                <a:latin typeface="Pretendard"/>
+              </a:rPr>
+              <a:t>③</a:t>
+            </a:r>
+          </a:p>
+        </p:txBody>
+      </p:sp>
+      <p:sp>
+        <p:nvSpPr>
+          <p:cNvPr id="26" name="TextBox 25"/>
           <p:cNvSpPr txBox="1"/>
           <p:nvPr/>
         </p:nvSpPr>
         <p:spPr>
           <a:xfrm>
-            <a:off x="1333500" y="3206750"/>
-            <a:ext cx="2984500" cy="584200"/>
+            <a:off x="1041400" y="3454400"/>
+            <a:ext cx="2540000" cy="457200"/>
           </a:xfrm>
           <a:prstGeom prst="rect">
             <a:avLst/>
@@ -3899,42 +4131,88 @@
           <a:noFill/>
         </p:spPr>
         <p:txBody>
-          <a:bodyPr wrap="square" lIns="25400" rIns="25400" tIns="12700" bIns="12700" anchor="ctr">
-            <a:spAutoFit/>
+          <a:bodyPr wrap="square" anchor="ctr" lIns="0" rIns="0" tIns="0" bIns="0">
+            <a:noAutofit/>
           </a:bodyPr>
           <a:lstStyle/>
           <a:p>
-            <a:r>
-              <a:rPr sz="1100" b="0">
-                <a:solidFill>
-                  <a:srgbClr val="4A5070"/>
-                </a:solidFill>
-                <a:latin typeface="Pretendard"/>
-              </a:rPr>
-              <a:t>[도구 1]로 경험 탐색·구조화. AI 질문에 답하고 프로젝트 자료로 역할·기여·성과 근거 확인.</a:t>
-            </a:r>
-          </a:p>
-        </p:txBody>
-      </p:sp>
-      <p:sp>
-        <p:nvSpPr>
-          <p:cNvPr id="22" name="Rectangle 21"/>
+            <a:pPr algn="l">
+              <a:lnSpc>
+                <a:spcPct val="100000"/>
+              </a:lnSpc>
+            </a:pPr>
+            <a:r>
+              <a:rPr sz="1500" b="1">
+                <a:solidFill>
+                  <a:srgbClr val="141A3C"/>
+                </a:solidFill>
+                <a:latin typeface="Pretendard"/>
+              </a:rPr>
+              <a:t>기술이력서 문장화</a:t>
+            </a:r>
+          </a:p>
+        </p:txBody>
+      </p:sp>
+      <p:sp>
+        <p:nvSpPr>
+          <p:cNvPr id="27" name="TextBox 26"/>
+          <p:cNvSpPr txBox="1"/>
+          <p:nvPr/>
+        </p:nvSpPr>
+        <p:spPr>
+          <a:xfrm>
+            <a:off x="3619500" y="3454400"/>
+            <a:ext cx="2286000" cy="457200"/>
+          </a:xfrm>
+          <a:prstGeom prst="rect">
+            <a:avLst/>
+          </a:prstGeom>
+          <a:noFill/>
+        </p:spPr>
+        <p:txBody>
+          <a:bodyPr wrap="square" anchor="ctr" lIns="0" rIns="0" tIns="0" bIns="0">
+            <a:noAutofit/>
+          </a:bodyPr>
+          <a:lstStyle/>
+          <a:p>
+            <a:pPr algn="l">
+              <a:lnSpc>
+                <a:spcPct val="100000"/>
+              </a:lnSpc>
+            </a:pPr>
+            <a:r>
+              <a:rPr sz="1250" b="1">
+                <a:solidFill>
+                  <a:srgbClr val="0E9F7A"/>
+                </a:solidFill>
+                <a:latin typeface="Pretendard"/>
+              </a:rPr>
+              <a:t>이력서 초안 · 핵심 문장 3개</a:t>
+            </a:r>
+          </a:p>
+        </p:txBody>
+      </p:sp>
+      <p:sp>
+        <p:nvSpPr>
+          <p:cNvPr id="28" name="Rectangle 27"/>
           <p:cNvSpPr/>
           <p:nvPr/>
         </p:nvSpPr>
         <p:spPr>
           <a:xfrm>
-            <a:off x="4381500" y="3219450"/>
-            <a:ext cx="1555750" cy="508000"/>
+            <a:off x="508000" y="3987800"/>
+            <a:ext cx="5461000" cy="457200"/>
           </a:xfrm>
           <a:prstGeom prst="rect">
             <a:avLst/>
           </a:prstGeom>
           <a:solidFill>
-            <a:srgbClr val="F3F5FA"/>
+            <a:srgbClr val="FFFFFF"/>
           </a:solidFill>
-          <a:ln>
-            <a:noFill/>
+          <a:ln w="9525">
+            <a:solidFill>
+              <a:srgbClr val="DDE1EE"/>
+            </a:solidFill>
           </a:ln>
           <a:effectLst/>
         </p:spPr>
@@ -3962,70 +4240,23 @@
       </p:sp>
       <p:sp>
         <p:nvSpPr>
-          <p:cNvPr id="23" name="TextBox 22"/>
-          <p:cNvSpPr txBox="1"/>
-          <p:nvPr/>
-        </p:nvSpPr>
-        <p:spPr>
-          <a:xfrm>
-            <a:off x="4419600" y="3219450"/>
-            <a:ext cx="1492250" cy="508000"/>
-          </a:xfrm>
-          <a:prstGeom prst="rect">
-            <a:avLst/>
-          </a:prstGeom>
-          <a:noFill/>
-        </p:spPr>
-        <p:txBody>
-          <a:bodyPr wrap="square" lIns="25400" rIns="25400" tIns="12700" bIns="12700" anchor="ctr">
-            <a:spAutoFit/>
-          </a:bodyPr>
-          <a:lstStyle/>
-          <a:p>
-            <a:r>
-              <a:rPr sz="900" b="1">
-                <a:solidFill>
-                  <a:srgbClr val="10A37F"/>
-                </a:solidFill>
-                <a:latin typeface="Pretendard"/>
-              </a:rPr>
-              <a:t>산출물</a:t>
-            </a:r>
-          </a:p>
-          <a:p>
-            <a:r>
-              <a:rPr sz="1100" b="1">
-                <a:solidFill>
-                  <a:srgbClr val="141A3C"/>
-                </a:solidFill>
-                <a:latin typeface="Pretendard"/>
-              </a:rPr>
-              <a:t>경험카드 1개 · 근거 자료 목록</a:t>
-            </a:r>
-          </a:p>
-        </p:txBody>
-      </p:sp>
-      <p:sp>
-        <p:nvSpPr>
-          <p:cNvPr id="24" name="Rectangle 23"/>
+          <p:cNvPr id="29" name="Oval 28"/>
           <p:cNvSpPr/>
           <p:nvPr/>
         </p:nvSpPr>
         <p:spPr>
           <a:xfrm>
-            <a:off x="381000" y="3854450"/>
-            <a:ext cx="5651500" cy="635000"/>
-          </a:xfrm>
-          <a:prstGeom prst="rect">
+            <a:off x="635000" y="4076700"/>
+            <a:ext cx="279400" cy="279400"/>
+          </a:xfrm>
+          <a:prstGeom prst="ellipse">
             <a:avLst/>
           </a:prstGeom>
           <a:solidFill>
-            <a:srgbClr val="FFFFFF"/>
+            <a:srgbClr val="0E9F7A"/>
           </a:solidFill>
-          <a:ln w="9525">
-            <a:solidFill>
-              <a:srgbClr val="DDE1EE"/>
-            </a:solidFill>
+          <a:ln>
+            <a:noFill/>
           </a:ln>
           <a:effectLst/>
         </p:spPr>
@@ -4053,23 +4284,209 @@
       </p:sp>
       <p:sp>
         <p:nvSpPr>
-          <p:cNvPr id="25" name="Rectangle 24"/>
+          <p:cNvPr id="30" name="TextBox 29"/>
+          <p:cNvSpPr txBox="1"/>
+          <p:nvPr/>
+        </p:nvSpPr>
+        <p:spPr>
+          <a:xfrm>
+            <a:off x="635000" y="4076700"/>
+            <a:ext cx="279400" cy="279400"/>
+          </a:xfrm>
+          <a:prstGeom prst="rect">
+            <a:avLst/>
+          </a:prstGeom>
+          <a:noFill/>
+        </p:spPr>
+        <p:txBody>
+          <a:bodyPr wrap="square" anchor="ctr" lIns="0" rIns="0" tIns="0" bIns="0">
+            <a:noAutofit/>
+          </a:bodyPr>
+          <a:lstStyle/>
+          <a:p>
+            <a:pPr algn="ctr">
+              <a:lnSpc>
+                <a:spcPct val="100000"/>
+              </a:lnSpc>
+            </a:pPr>
+            <a:r>
+              <a:rPr sz="1500" b="1">
+                <a:solidFill>
+                  <a:srgbClr val="FFFFFF"/>
+                </a:solidFill>
+                <a:latin typeface="Pretendard"/>
+              </a:rPr>
+              <a:t>④</a:t>
+            </a:r>
+          </a:p>
+        </p:txBody>
+      </p:sp>
+      <p:sp>
+        <p:nvSpPr>
+          <p:cNvPr id="31" name="TextBox 30"/>
+          <p:cNvSpPr txBox="1"/>
+          <p:nvPr/>
+        </p:nvSpPr>
+        <p:spPr>
+          <a:xfrm>
+            <a:off x="1041400" y="3987800"/>
+            <a:ext cx="2540000" cy="457200"/>
+          </a:xfrm>
+          <a:prstGeom prst="rect">
+            <a:avLst/>
+          </a:prstGeom>
+          <a:noFill/>
+        </p:spPr>
+        <p:txBody>
+          <a:bodyPr wrap="square" anchor="ctr" lIns="0" rIns="0" tIns="0" bIns="0">
+            <a:noAutofit/>
+          </a:bodyPr>
+          <a:lstStyle/>
+          <a:p>
+            <a:pPr algn="l">
+              <a:lnSpc>
+                <a:spcPct val="100000"/>
+              </a:lnSpc>
+            </a:pPr>
+            <a:r>
+              <a:rPr sz="1500" b="1">
+                <a:solidFill>
+                  <a:srgbClr val="141A3C"/>
+                </a:solidFill>
+                <a:latin typeface="Pretendard"/>
+              </a:rPr>
+              <a:t>자기소개서 작성</a:t>
+            </a:r>
+            <a:r>
+              <a:rPr sz="1200" b="0">
+                <a:solidFill>
+                  <a:srgbClr val="4A5070"/>
+                </a:solidFill>
+                <a:latin typeface="Pretendard"/>
+              </a:rPr>
+              <a:t>   </a:t>
+            </a:r>
+            <a:r>
+              <a:rPr sz="1100" b="1" u="sng">
+                <a:solidFill>
+                  <a:srgbClr val="0E9F7A"/>
+                </a:solidFill>
+                <a:latin typeface="Pretendard"/>
+                <a:hlinkClick r:id="rId3"/>
+              </a:rPr>
+              <a:t>도구 2</a:t>
+            </a:r>
+          </a:p>
+        </p:txBody>
+      </p:sp>
+      <p:sp>
+        <p:nvSpPr>
+          <p:cNvPr id="32" name="TextBox 31"/>
+          <p:cNvSpPr txBox="1"/>
+          <p:nvPr/>
+        </p:nvSpPr>
+        <p:spPr>
+          <a:xfrm>
+            <a:off x="3619500" y="3987800"/>
+            <a:ext cx="2286000" cy="457200"/>
+          </a:xfrm>
+          <a:prstGeom prst="rect">
+            <a:avLst/>
+          </a:prstGeom>
+          <a:noFill/>
+        </p:spPr>
+        <p:txBody>
+          <a:bodyPr wrap="square" anchor="ctr" lIns="0" rIns="0" tIns="0" bIns="0">
+            <a:noAutofit/>
+          </a:bodyPr>
+          <a:lstStyle/>
+          <a:p>
+            <a:pPr algn="l">
+              <a:lnSpc>
+                <a:spcPct val="100000"/>
+              </a:lnSpc>
+            </a:pPr>
+            <a:r>
+              <a:rPr sz="1250" b="1">
+                <a:solidFill>
+                  <a:srgbClr val="0E9F7A"/>
+                </a:solidFill>
+                <a:latin typeface="Pretendard"/>
+              </a:rPr>
+              <a:t>자소서 1문항 · 이력서 수정본</a:t>
+            </a:r>
+          </a:p>
+        </p:txBody>
+      </p:sp>
+      <p:sp>
+        <p:nvSpPr>
+          <p:cNvPr id="33" name="TextBox 32"/>
+          <p:cNvSpPr txBox="1"/>
+          <p:nvPr/>
+        </p:nvSpPr>
+        <p:spPr>
+          <a:xfrm>
+            <a:off x="6223000" y="2095500"/>
+            <a:ext cx="5461000" cy="190500"/>
+          </a:xfrm>
+          <a:prstGeom prst="rect">
+            <a:avLst/>
+          </a:prstGeom>
+          <a:noFill/>
+        </p:spPr>
+        <p:txBody>
+          <a:bodyPr wrap="square" anchor="t" lIns="0" rIns="0" tIns="0" bIns="0">
+            <a:noAutofit/>
+          </a:bodyPr>
+          <a:lstStyle/>
+          <a:p>
+            <a:pPr algn="l">
+              <a:lnSpc>
+                <a:spcPct val="115000"/>
+              </a:lnSpc>
+            </a:pPr>
+            <a:r>
+              <a:rPr sz="1500" b="1">
+                <a:solidFill>
+                  <a:srgbClr val="6C4CF5"/>
+                </a:solidFill>
+                <a:latin typeface="Pretendard"/>
+              </a:rPr>
+              <a:t>2회기  포트폴리오 · 면접</a:t>
+            </a:r>
+            <a:r>
+              <a:rPr sz="1100" b="0">
+                <a:solidFill>
+                  <a:srgbClr val="8A90A8"/>
+                </a:solidFill>
+                <a:latin typeface="Pretendard"/>
+              </a:rPr>
+              <a:t>   8시간 · 2시간 × 4모듈</a:t>
+            </a:r>
+          </a:p>
+        </p:txBody>
+      </p:sp>
+      <p:sp>
+        <p:nvSpPr>
+          <p:cNvPr id="34" name="Rectangle 33"/>
           <p:cNvSpPr/>
           <p:nvPr/>
         </p:nvSpPr>
         <p:spPr>
           <a:xfrm>
-            <a:off x="381000" y="3854450"/>
-            <a:ext cx="50800" cy="635000"/>
+            <a:off x="6223000" y="2387600"/>
+            <a:ext cx="5461000" cy="457200"/>
           </a:xfrm>
           <a:prstGeom prst="rect">
             <a:avLst/>
           </a:prstGeom>
           <a:solidFill>
-            <a:srgbClr val="10A37F"/>
+            <a:srgbClr val="FFFFFF"/>
           </a:solidFill>
-          <a:ln>
-            <a:noFill/>
+          <a:ln w="9525">
+            <a:solidFill>
+              <a:srgbClr val="DDE1EE"/>
+            </a:solidFill>
           </a:ln>
           <a:effectLst/>
         </p:spPr>
@@ -4097,99 +4514,20 @@
       </p:sp>
       <p:sp>
         <p:nvSpPr>
-          <p:cNvPr id="26" name="TextBox 25"/>
-          <p:cNvSpPr txBox="1"/>
-          <p:nvPr/>
-        </p:nvSpPr>
-        <p:spPr>
-          <a:xfrm>
-            <a:off x="508000" y="3905250"/>
-            <a:ext cx="825500" cy="571500"/>
-          </a:xfrm>
-          <a:prstGeom prst="rect">
-            <a:avLst/>
-          </a:prstGeom>
-          <a:noFill/>
-        </p:spPr>
-        <p:txBody>
-          <a:bodyPr wrap="square" lIns="25400" rIns="25400" tIns="12700" bIns="12700" anchor="ctr">
-            <a:spAutoFit/>
-          </a:bodyPr>
-          <a:lstStyle/>
-          <a:p>
-            <a:r>
-              <a:rPr sz="1300" b="1">
-                <a:solidFill>
-                  <a:srgbClr val="141A3C"/>
-                </a:solidFill>
-                <a:latin typeface="Pretendard"/>
-              </a:rPr>
-              <a:t>1회기 ③</a:t>
-            </a:r>
-          </a:p>
-          <a:p>
-            <a:r>
-              <a:rPr sz="1100" b="0">
-                <a:solidFill>
-                  <a:srgbClr val="4A5070"/>
-                </a:solidFill>
-                <a:latin typeface="Pretendard"/>
-              </a:rPr>
-              <a:t>2시간</a:t>
-            </a:r>
-          </a:p>
-        </p:txBody>
-      </p:sp>
-      <p:sp>
-        <p:nvSpPr>
-          <p:cNvPr id="27" name="TextBox 26"/>
-          <p:cNvSpPr txBox="1"/>
-          <p:nvPr/>
-        </p:nvSpPr>
-        <p:spPr>
-          <a:xfrm>
-            <a:off x="1333500" y="3905250"/>
-            <a:ext cx="2984500" cy="584200"/>
-          </a:xfrm>
-          <a:prstGeom prst="rect">
-            <a:avLst/>
-          </a:prstGeom>
-          <a:noFill/>
-        </p:spPr>
-        <p:txBody>
-          <a:bodyPr wrap="square" lIns="25400" rIns="25400" tIns="12700" bIns="12700" anchor="ctr">
-            <a:spAutoFit/>
-          </a:bodyPr>
-          <a:lstStyle/>
-          <a:p>
-            <a:r>
-              <a:rPr sz="1100" b="0">
-                <a:solidFill>
-                  <a:srgbClr val="4A5070"/>
-                </a:solidFill>
-                <a:latin typeface="Pretendard"/>
-              </a:rPr>
-              <a:t>AI로 경험카드를 기술이력서 문장으로 변환. 기술·행동·기여 구분, 수치·표현 수정.</a:t>
-            </a:r>
-          </a:p>
-        </p:txBody>
-      </p:sp>
-      <p:sp>
-        <p:nvSpPr>
-          <p:cNvPr id="28" name="Rectangle 27"/>
+          <p:cNvPr id="35" name="Oval 34"/>
           <p:cNvSpPr/>
           <p:nvPr/>
         </p:nvSpPr>
         <p:spPr>
           <a:xfrm>
-            <a:off x="4381500" y="3917950"/>
-            <a:ext cx="1555750" cy="508000"/>
-          </a:xfrm>
-          <a:prstGeom prst="rect">
+            <a:off x="6350000" y="2476500"/>
+            <a:ext cx="279400" cy="279400"/>
+          </a:xfrm>
+          <a:prstGeom prst="ellipse">
             <a:avLst/>
           </a:prstGeom>
           <a:solidFill>
-            <a:srgbClr val="F3F5FA"/>
+            <a:srgbClr val="6C4CF5"/>
           </a:solidFill>
           <a:ln>
             <a:noFill/>
@@ -4220,14 +4558,14 @@
       </p:sp>
       <p:sp>
         <p:nvSpPr>
-          <p:cNvPr id="29" name="TextBox 28"/>
+          <p:cNvPr id="36" name="TextBox 35"/>
           <p:cNvSpPr txBox="1"/>
           <p:nvPr/>
         </p:nvSpPr>
         <p:spPr>
           <a:xfrm>
-            <a:off x="4419600" y="3917950"/>
-            <a:ext cx="1492250" cy="508000"/>
+            <a:off x="6350000" y="2476500"/>
+            <a:ext cx="279400" cy="279400"/>
           </a:xfrm>
           <a:prstGeom prst="rect">
             <a:avLst/>
@@ -4235,44 +4573,116 @@
           <a:noFill/>
         </p:spPr>
         <p:txBody>
-          <a:bodyPr wrap="square" lIns="25400" rIns="25400" tIns="12700" bIns="12700" anchor="ctr">
-            <a:spAutoFit/>
+          <a:bodyPr wrap="square" anchor="ctr" lIns="0" rIns="0" tIns="0" bIns="0">
+            <a:noAutofit/>
           </a:bodyPr>
           <a:lstStyle/>
           <a:p>
-            <a:r>
-              <a:rPr sz="900" b="1">
-                <a:solidFill>
-                  <a:srgbClr val="10A37F"/>
-                </a:solidFill>
-                <a:latin typeface="Pretendard"/>
-              </a:rPr>
-              <a:t>산출물</a:t>
-            </a:r>
-          </a:p>
-          <a:p>
-            <a:r>
-              <a:rPr sz="1100" b="1">
+            <a:pPr algn="ctr">
+              <a:lnSpc>
+                <a:spcPct val="100000"/>
+              </a:lnSpc>
+            </a:pPr>
+            <a:r>
+              <a:rPr sz="1500" b="1">
+                <a:solidFill>
+                  <a:srgbClr val="FFFFFF"/>
+                </a:solidFill>
+                <a:latin typeface="Pretendard"/>
+              </a:rPr>
+              <a:t>①</a:t>
+            </a:r>
+          </a:p>
+        </p:txBody>
+      </p:sp>
+      <p:sp>
+        <p:nvSpPr>
+          <p:cNvPr id="37" name="TextBox 36"/>
+          <p:cNvSpPr txBox="1"/>
+          <p:nvPr/>
+        </p:nvSpPr>
+        <p:spPr>
+          <a:xfrm>
+            <a:off x="6756400" y="2387600"/>
+            <a:ext cx="2540000" cy="457200"/>
+          </a:xfrm>
+          <a:prstGeom prst="rect">
+            <a:avLst/>
+          </a:prstGeom>
+          <a:noFill/>
+        </p:spPr>
+        <p:txBody>
+          <a:bodyPr wrap="square" anchor="ctr" lIns="0" rIns="0" tIns="0" bIns="0">
+            <a:noAutofit/>
+          </a:bodyPr>
+          <a:lstStyle/>
+          <a:p>
+            <a:pPr algn="l">
+              <a:lnSpc>
+                <a:spcPct val="100000"/>
+              </a:lnSpc>
+            </a:pPr>
+            <a:r>
+              <a:rPr sz="1500" b="1">
                 <a:solidFill>
                   <a:srgbClr val="141A3C"/>
                 </a:solidFill>
                 <a:latin typeface="Pretendard"/>
               </a:rPr>
-              <a:t>기술이력서 초안 · 핵심 문장 3개</a:t>
-            </a:r>
-          </a:p>
-        </p:txBody>
-      </p:sp>
-      <p:sp>
-        <p:nvSpPr>
-          <p:cNvPr id="30" name="Rectangle 29"/>
+              <a:t>프로젝트 설명 설계</a:t>
+            </a:r>
+          </a:p>
+        </p:txBody>
+      </p:sp>
+      <p:sp>
+        <p:nvSpPr>
+          <p:cNvPr id="38" name="TextBox 37"/>
+          <p:cNvSpPr txBox="1"/>
+          <p:nvPr/>
+        </p:nvSpPr>
+        <p:spPr>
+          <a:xfrm>
+            <a:off x="9334500" y="2387600"/>
+            <a:ext cx="2286000" cy="457200"/>
+          </a:xfrm>
+          <a:prstGeom prst="rect">
+            <a:avLst/>
+          </a:prstGeom>
+          <a:noFill/>
+        </p:spPr>
+        <p:txBody>
+          <a:bodyPr wrap="square" anchor="ctr" lIns="0" rIns="0" tIns="0" bIns="0">
+            <a:noAutofit/>
+          </a:bodyPr>
+          <a:lstStyle/>
+          <a:p>
+            <a:pPr algn="l">
+              <a:lnSpc>
+                <a:spcPct val="100000"/>
+              </a:lnSpc>
+            </a:pPr>
+            <a:r>
+              <a:rPr sz="1250" b="1">
+                <a:solidFill>
+                  <a:srgbClr val="6C4CF5"/>
+                </a:solidFill>
+                <a:latin typeface="Pretendard"/>
+              </a:rPr>
+              <a:t>설명 원고 · 한계 점검표</a:t>
+            </a:r>
+          </a:p>
+        </p:txBody>
+      </p:sp>
+      <p:sp>
+        <p:nvSpPr>
+          <p:cNvPr id="39" name="Rectangle 38"/>
           <p:cNvSpPr/>
           <p:nvPr/>
         </p:nvSpPr>
         <p:spPr>
           <a:xfrm>
-            <a:off x="381000" y="4552950"/>
-            <a:ext cx="5651500" cy="635000"/>
+            <a:off x="6223000" y="2921000"/>
+            <a:ext cx="5461000" cy="457200"/>
           </a:xfrm>
           <a:prstGeom prst="rect">
             <a:avLst/>
@@ -4311,20 +4721,20 @@
       </p:sp>
       <p:sp>
         <p:nvSpPr>
-          <p:cNvPr id="31" name="Rectangle 30"/>
+          <p:cNvPr id="40" name="Oval 39"/>
           <p:cNvSpPr/>
           <p:nvPr/>
         </p:nvSpPr>
         <p:spPr>
           <a:xfrm>
-            <a:off x="381000" y="4552950"/>
-            <a:ext cx="50800" cy="635000"/>
-          </a:xfrm>
-          <a:prstGeom prst="rect">
+            <a:off x="6350000" y="3009900"/>
+            <a:ext cx="279400" cy="279400"/>
+          </a:xfrm>
+          <a:prstGeom prst="ellipse">
             <a:avLst/>
           </a:prstGeom>
           <a:solidFill>
-            <a:srgbClr val="10A37F"/>
+            <a:srgbClr val="6C4CF5"/>
           </a:solidFill>
           <a:ln>
             <a:noFill/>
@@ -4355,14 +4765,14 @@
       </p:sp>
       <p:sp>
         <p:nvSpPr>
-          <p:cNvPr id="32" name="TextBox 31"/>
+          <p:cNvPr id="41" name="TextBox 40"/>
           <p:cNvSpPr txBox="1"/>
           <p:nvPr/>
         </p:nvSpPr>
         <p:spPr>
           <a:xfrm>
-            <a:off x="508000" y="4603750"/>
-            <a:ext cx="825500" cy="571500"/>
+            <a:off x="6350000" y="3009900"/>
+            <a:ext cx="279400" cy="279400"/>
           </a:xfrm>
           <a:prstGeom prst="rect">
             <a:avLst/>
@@ -4370,44 +4780,38 @@
           <a:noFill/>
         </p:spPr>
         <p:txBody>
-          <a:bodyPr wrap="square" lIns="25400" rIns="25400" tIns="12700" bIns="12700" anchor="ctr">
-            <a:spAutoFit/>
+          <a:bodyPr wrap="square" anchor="ctr" lIns="0" rIns="0" tIns="0" bIns="0">
+            <a:noAutofit/>
           </a:bodyPr>
           <a:lstStyle/>
           <a:p>
-            <a:r>
-              <a:rPr sz="1300" b="1">
-                <a:solidFill>
-                  <a:srgbClr val="141A3C"/>
-                </a:solidFill>
-                <a:latin typeface="Pretendard"/>
-              </a:rPr>
-              <a:t>1회기 ④</a:t>
-            </a:r>
-          </a:p>
-          <a:p>
-            <a:r>
-              <a:rPr sz="1100" b="0">
-                <a:solidFill>
-                  <a:srgbClr val="4A5070"/>
-                </a:solidFill>
-                <a:latin typeface="Pretendard"/>
-              </a:rPr>
-              <a:t>2시간</a:t>
-            </a:r>
-          </a:p>
-        </p:txBody>
-      </p:sp>
-      <p:sp>
-        <p:nvSpPr>
-          <p:cNvPr id="33" name="TextBox 32"/>
+            <a:pPr algn="ctr">
+              <a:lnSpc>
+                <a:spcPct val="100000"/>
+              </a:lnSpc>
+            </a:pPr>
+            <a:r>
+              <a:rPr sz="1500" b="1">
+                <a:solidFill>
+                  <a:srgbClr val="FFFFFF"/>
+                </a:solidFill>
+                <a:latin typeface="Pretendard"/>
+              </a:rPr>
+              <a:t>②</a:t>
+            </a:r>
+          </a:p>
+        </p:txBody>
+      </p:sp>
+      <p:sp>
+        <p:nvSpPr>
+          <p:cNvPr id="42" name="TextBox 41"/>
           <p:cNvSpPr txBox="1"/>
           <p:nvPr/>
         </p:nvSpPr>
         <p:spPr>
           <a:xfrm>
-            <a:off x="1333500" y="4603750"/>
-            <a:ext cx="2984500" cy="584200"/>
+            <a:off x="6756400" y="2921000"/>
+            <a:ext cx="2540000" cy="457200"/>
           </a:xfrm>
           <a:prstGeom prst="rect">
             <a:avLst/>
@@ -4415,42 +4819,107 @@
           <a:noFill/>
         </p:spPr>
         <p:txBody>
-          <a:bodyPr wrap="square" lIns="25400" rIns="25400" tIns="12700" bIns="12700" anchor="ctr">
-            <a:spAutoFit/>
+          <a:bodyPr wrap="square" anchor="ctr" lIns="0" rIns="0" tIns="0" bIns="0">
+            <a:noAutofit/>
           </a:bodyPr>
           <a:lstStyle/>
           <a:p>
-            <a:r>
-              <a:rPr sz="1100" b="0">
+            <a:pPr algn="l">
+              <a:lnSpc>
+                <a:spcPct val="100000"/>
+              </a:lnSpc>
+            </a:pPr>
+            <a:r>
+              <a:rPr sz="1500" b="1">
+                <a:solidFill>
+                  <a:srgbClr val="141A3C"/>
+                </a:solidFill>
+                <a:latin typeface="Pretendard"/>
+              </a:rPr>
+              <a:t>포트폴리오 소개</a:t>
+            </a:r>
+            <a:r>
+              <a:rPr sz="1200" b="0">
                 <a:solidFill>
                   <a:srgbClr val="4A5070"/>
                 </a:solidFill>
                 <a:latin typeface="Pretendard"/>
               </a:rPr>
-              <a:t>[도구 2]로 기업·경험 기반 자기소개서 작성. 피드백 후 허위·과장 제거, 이력서와 일치 검토.</a:t>
-            </a:r>
-          </a:p>
-        </p:txBody>
-      </p:sp>
-      <p:sp>
-        <p:nvSpPr>
-          <p:cNvPr id="34" name="Rectangle 33"/>
+              <a:t>   </a:t>
+            </a:r>
+            <a:r>
+              <a:rPr sz="1100" b="1" u="sng">
+                <a:solidFill>
+                  <a:srgbClr val="6C4CF5"/>
+                </a:solidFill>
+                <a:latin typeface="Pretendard"/>
+                <a:hlinkClick r:id="rId4"/>
+              </a:rPr>
+              <a:t>도구 3</a:t>
+            </a:r>
+          </a:p>
+        </p:txBody>
+      </p:sp>
+      <p:sp>
+        <p:nvSpPr>
+          <p:cNvPr id="43" name="TextBox 42"/>
+          <p:cNvSpPr txBox="1"/>
+          <p:nvPr/>
+        </p:nvSpPr>
+        <p:spPr>
+          <a:xfrm>
+            <a:off x="9334500" y="2921000"/>
+            <a:ext cx="2286000" cy="457200"/>
+          </a:xfrm>
+          <a:prstGeom prst="rect">
+            <a:avLst/>
+          </a:prstGeom>
+          <a:noFill/>
+        </p:spPr>
+        <p:txBody>
+          <a:bodyPr wrap="square" anchor="ctr" lIns="0" rIns="0" tIns="0" bIns="0">
+            <a:noAutofit/>
+          </a:bodyPr>
+          <a:lstStyle/>
+          <a:p>
+            <a:pPr algn="l">
+              <a:lnSpc>
+                <a:spcPct val="100000"/>
+              </a:lnSpc>
+            </a:pPr>
+            <a:r>
+              <a:rPr sz="1250" b="1">
+                <a:solidFill>
+                  <a:srgbClr val="6C4CF5"/>
+                </a:solidFill>
+                <a:latin typeface="Pretendard"/>
+              </a:rPr>
+              <a:t>소개 1쪽 수정본</a:t>
+            </a:r>
+          </a:p>
+        </p:txBody>
+      </p:sp>
+      <p:sp>
+        <p:nvSpPr>
+          <p:cNvPr id="44" name="Rectangle 43"/>
           <p:cNvSpPr/>
           <p:nvPr/>
         </p:nvSpPr>
         <p:spPr>
           <a:xfrm>
-            <a:off x="4381500" y="4616450"/>
-            <a:ext cx="1555750" cy="508000"/>
+            <a:off x="6223000" y="3454400"/>
+            <a:ext cx="5461000" cy="457200"/>
           </a:xfrm>
           <a:prstGeom prst="rect">
             <a:avLst/>
           </a:prstGeom>
           <a:solidFill>
-            <a:srgbClr val="F3F5FA"/>
+            <a:srgbClr val="FFFFFF"/>
           </a:solidFill>
-          <a:ln>
-            <a:noFill/>
+          <a:ln w="9525">
+            <a:solidFill>
+              <a:srgbClr val="DDE1EE"/>
+            </a:solidFill>
           </a:ln>
           <a:effectLst/>
         </p:spPr>
@@ -4478,104 +4947,23 @@
       </p:sp>
       <p:sp>
         <p:nvSpPr>
-          <p:cNvPr id="35" name="TextBox 34"/>
-          <p:cNvSpPr txBox="1"/>
-          <p:nvPr/>
-        </p:nvSpPr>
-        <p:spPr>
-          <a:xfrm>
-            <a:off x="4419600" y="4616450"/>
-            <a:ext cx="1492250" cy="508000"/>
-          </a:xfrm>
-          <a:prstGeom prst="rect">
-            <a:avLst/>
-          </a:prstGeom>
-          <a:noFill/>
-        </p:spPr>
-        <p:txBody>
-          <a:bodyPr wrap="square" lIns="25400" rIns="25400" tIns="12700" bIns="12700" anchor="ctr">
-            <a:spAutoFit/>
-          </a:bodyPr>
-          <a:lstStyle/>
-          <a:p>
-            <a:r>
-              <a:rPr sz="900" b="1">
-                <a:solidFill>
-                  <a:srgbClr val="10A37F"/>
-                </a:solidFill>
-                <a:latin typeface="Pretendard"/>
-              </a:rPr>
-              <a:t>산출물</a:t>
-            </a:r>
-          </a:p>
-          <a:p>
-            <a:r>
-              <a:rPr sz="1100" b="1">
-                <a:solidFill>
-                  <a:srgbClr val="141A3C"/>
-                </a:solidFill>
-                <a:latin typeface="Pretendard"/>
-              </a:rPr>
-              <a:t>자기소개서 1문항 · 이력서 수정본</a:t>
-            </a:r>
-          </a:p>
-        </p:txBody>
-      </p:sp>
-      <p:sp>
-        <p:nvSpPr>
-          <p:cNvPr id="36" name="TextBox 35"/>
-          <p:cNvSpPr txBox="1"/>
-          <p:nvPr/>
-        </p:nvSpPr>
-        <p:spPr>
-          <a:xfrm>
-            <a:off x="6159500" y="2190750"/>
-            <a:ext cx="5651500" cy="228600"/>
-          </a:xfrm>
-          <a:prstGeom prst="rect">
-            <a:avLst/>
-          </a:prstGeom>
-          <a:noFill/>
-        </p:spPr>
-        <p:txBody>
-          <a:bodyPr wrap="square" lIns="25400" rIns="25400" tIns="12700" bIns="12700">
-            <a:spAutoFit/>
-          </a:bodyPr>
-          <a:lstStyle/>
-          <a:p>
-            <a:r>
-              <a:rPr sz="1400" b="1">
-                <a:solidFill>
-                  <a:srgbClr val="6C4CF5"/>
-                </a:solidFill>
-                <a:latin typeface="Pretendard"/>
-              </a:rPr>
-              <a:t>2회기 · 포트폴리오·면접 (8시간)</a:t>
-            </a:r>
-          </a:p>
-        </p:txBody>
-      </p:sp>
-      <p:sp>
-        <p:nvSpPr>
-          <p:cNvPr id="37" name="Rectangle 36"/>
+          <p:cNvPr id="45" name="Oval 44"/>
           <p:cNvSpPr/>
           <p:nvPr/>
         </p:nvSpPr>
         <p:spPr>
           <a:xfrm>
-            <a:off x="6159500" y="2457450"/>
-            <a:ext cx="5651500" cy="635000"/>
-          </a:xfrm>
-          <a:prstGeom prst="rect">
+            <a:off x="6350000" y="3543300"/>
+            <a:ext cx="279400" cy="279400"/>
+          </a:xfrm>
+          <a:prstGeom prst="ellipse">
             <a:avLst/>
           </a:prstGeom>
           <a:solidFill>
-            <a:srgbClr val="FFFFFF"/>
+            <a:srgbClr val="6C4CF5"/>
           </a:solidFill>
-          <a:ln w="9525">
-            <a:solidFill>
-              <a:srgbClr val="DDE1EE"/>
-            </a:solidFill>
+          <a:ln>
+            <a:noFill/>
           </a:ln>
           <a:effectLst/>
         </p:spPr>
@@ -4603,23 +4991,142 @@
       </p:sp>
       <p:sp>
         <p:nvSpPr>
-          <p:cNvPr id="38" name="Rectangle 37"/>
+          <p:cNvPr id="46" name="TextBox 45"/>
+          <p:cNvSpPr txBox="1"/>
+          <p:nvPr/>
+        </p:nvSpPr>
+        <p:spPr>
+          <a:xfrm>
+            <a:off x="6350000" y="3543300"/>
+            <a:ext cx="279400" cy="279400"/>
+          </a:xfrm>
+          <a:prstGeom prst="rect">
+            <a:avLst/>
+          </a:prstGeom>
+          <a:noFill/>
+        </p:spPr>
+        <p:txBody>
+          <a:bodyPr wrap="square" anchor="ctr" lIns="0" rIns="0" tIns="0" bIns="0">
+            <a:noAutofit/>
+          </a:bodyPr>
+          <a:lstStyle/>
+          <a:p>
+            <a:pPr algn="ctr">
+              <a:lnSpc>
+                <a:spcPct val="100000"/>
+              </a:lnSpc>
+            </a:pPr>
+            <a:r>
+              <a:rPr sz="1500" b="1">
+                <a:solidFill>
+                  <a:srgbClr val="FFFFFF"/>
+                </a:solidFill>
+                <a:latin typeface="Pretendard"/>
+              </a:rPr>
+              <a:t>③</a:t>
+            </a:r>
+          </a:p>
+        </p:txBody>
+      </p:sp>
+      <p:sp>
+        <p:nvSpPr>
+          <p:cNvPr id="47" name="TextBox 46"/>
+          <p:cNvSpPr txBox="1"/>
+          <p:nvPr/>
+        </p:nvSpPr>
+        <p:spPr>
+          <a:xfrm>
+            <a:off x="6756400" y="3454400"/>
+            <a:ext cx="2540000" cy="457200"/>
+          </a:xfrm>
+          <a:prstGeom prst="rect">
+            <a:avLst/>
+          </a:prstGeom>
+          <a:noFill/>
+        </p:spPr>
+        <p:txBody>
+          <a:bodyPr wrap="square" anchor="ctr" lIns="0" rIns="0" tIns="0" bIns="0">
+            <a:noAutofit/>
+          </a:bodyPr>
+          <a:lstStyle/>
+          <a:p>
+            <a:pPr algn="l">
+              <a:lnSpc>
+                <a:spcPct val="100000"/>
+              </a:lnSpc>
+            </a:pPr>
+            <a:r>
+              <a:rPr sz="1500" b="1">
+                <a:solidFill>
+                  <a:srgbClr val="141A3C"/>
+                </a:solidFill>
+                <a:latin typeface="Pretendard"/>
+              </a:rPr>
+              <a:t>GitHub README 작성</a:t>
+            </a:r>
+          </a:p>
+        </p:txBody>
+      </p:sp>
+      <p:sp>
+        <p:nvSpPr>
+          <p:cNvPr id="48" name="TextBox 47"/>
+          <p:cNvSpPr txBox="1"/>
+          <p:nvPr/>
+        </p:nvSpPr>
+        <p:spPr>
+          <a:xfrm>
+            <a:off x="9334500" y="3454400"/>
+            <a:ext cx="2286000" cy="457200"/>
+          </a:xfrm>
+          <a:prstGeom prst="rect">
+            <a:avLst/>
+          </a:prstGeom>
+          <a:noFill/>
+        </p:spPr>
+        <p:txBody>
+          <a:bodyPr wrap="square" anchor="ctr" lIns="0" rIns="0" tIns="0" bIns="0">
+            <a:noAutofit/>
+          </a:bodyPr>
+          <a:lstStyle/>
+          <a:p>
+            <a:pPr algn="l">
+              <a:lnSpc>
+                <a:spcPct val="100000"/>
+              </a:lnSpc>
+            </a:pPr>
+            <a:r>
+              <a:rPr sz="1250" b="1">
+                <a:solidFill>
+                  <a:srgbClr val="6C4CF5"/>
+                </a:solidFill>
+                <a:latin typeface="Pretendard"/>
+              </a:rPr>
+              <a:t>README · 일관성 체크</a:t>
+            </a:r>
+          </a:p>
+        </p:txBody>
+      </p:sp>
+      <p:sp>
+        <p:nvSpPr>
+          <p:cNvPr id="49" name="Rectangle 48"/>
           <p:cNvSpPr/>
           <p:nvPr/>
         </p:nvSpPr>
         <p:spPr>
           <a:xfrm>
-            <a:off x="6159500" y="2457450"/>
-            <a:ext cx="50800" cy="635000"/>
+            <a:off x="6223000" y="3987800"/>
+            <a:ext cx="5461000" cy="457200"/>
           </a:xfrm>
           <a:prstGeom prst="rect">
             <a:avLst/>
           </a:prstGeom>
           <a:solidFill>
-            <a:srgbClr val="6C4CF5"/>
+            <a:srgbClr val="FFFFFF"/>
           </a:solidFill>
-          <a:ln>
-            <a:noFill/>
+          <a:ln w="9525">
+            <a:solidFill>
+              <a:srgbClr val="DDE1EE"/>
+            </a:solidFill>
           </a:ln>
           <a:effectLst/>
         </p:spPr>
@@ -4647,99 +5154,20 @@
       </p:sp>
       <p:sp>
         <p:nvSpPr>
-          <p:cNvPr id="39" name="TextBox 38"/>
-          <p:cNvSpPr txBox="1"/>
-          <p:nvPr/>
-        </p:nvSpPr>
-        <p:spPr>
-          <a:xfrm>
-            <a:off x="6286500" y="2508250"/>
-            <a:ext cx="825500" cy="571500"/>
-          </a:xfrm>
-          <a:prstGeom prst="rect">
-            <a:avLst/>
-          </a:prstGeom>
-          <a:noFill/>
-        </p:spPr>
-        <p:txBody>
-          <a:bodyPr wrap="square" lIns="25400" rIns="25400" tIns="12700" bIns="12700" anchor="ctr">
-            <a:spAutoFit/>
-          </a:bodyPr>
-          <a:lstStyle/>
-          <a:p>
-            <a:r>
-              <a:rPr sz="1300" b="1">
-                <a:solidFill>
-                  <a:srgbClr val="141A3C"/>
-                </a:solidFill>
-                <a:latin typeface="Pretendard"/>
-              </a:rPr>
-              <a:t>2회기 ①</a:t>
-            </a:r>
-          </a:p>
-          <a:p>
-            <a:r>
-              <a:rPr sz="1100" b="0">
-                <a:solidFill>
-                  <a:srgbClr val="4A5070"/>
-                </a:solidFill>
-                <a:latin typeface="Pretendard"/>
-              </a:rPr>
-              <a:t>2시간</a:t>
-            </a:r>
-          </a:p>
-        </p:txBody>
-      </p:sp>
-      <p:sp>
-        <p:nvSpPr>
-          <p:cNvPr id="40" name="TextBox 39"/>
-          <p:cNvSpPr txBox="1"/>
-          <p:nvPr/>
-        </p:nvSpPr>
-        <p:spPr>
-          <a:xfrm>
-            <a:off x="7112000" y="2508250"/>
-            <a:ext cx="2984500" cy="584200"/>
-          </a:xfrm>
-          <a:prstGeom prst="rect">
-            <a:avLst/>
-          </a:prstGeom>
-          <a:noFill/>
-        </p:spPr>
-        <p:txBody>
-          <a:bodyPr wrap="square" lIns="25400" rIns="25400" tIns="12700" bIns="12700" anchor="ctr">
-            <a:spAutoFit/>
-          </a:bodyPr>
-          <a:lstStyle/>
-          <a:p>
-            <a:r>
-              <a:rPr sz="1100" b="0">
-                <a:solidFill>
-                  <a:srgbClr val="4A5070"/>
-                </a:solidFill>
-                <a:latin typeface="Pretendard"/>
-              </a:rPr>
-              <a:t>AI로 프로젝트 설명 구조·보완 질문 생성. 데이터·접근법·평가 조건·한계를 실제 자료와 대조.</a:t>
-            </a:r>
-          </a:p>
-        </p:txBody>
-      </p:sp>
-      <p:sp>
-        <p:nvSpPr>
-          <p:cNvPr id="41" name="Rectangle 40"/>
+          <p:cNvPr id="50" name="Oval 49"/>
           <p:cNvSpPr/>
           <p:nvPr/>
         </p:nvSpPr>
         <p:spPr>
           <a:xfrm>
-            <a:off x="10160000" y="2520950"/>
-            <a:ext cx="1555750" cy="508000"/>
-          </a:xfrm>
-          <a:prstGeom prst="rect">
+            <a:off x="6350000" y="4076700"/>
+            <a:ext cx="279400" cy="279400"/>
+          </a:xfrm>
+          <a:prstGeom prst="ellipse">
             <a:avLst/>
           </a:prstGeom>
           <a:solidFill>
-            <a:srgbClr val="F3F5FA"/>
+            <a:srgbClr val="6C4CF5"/>
           </a:solidFill>
           <a:ln>
             <a:noFill/>
@@ -4770,14 +5198,14 @@
       </p:sp>
       <p:sp>
         <p:nvSpPr>
-          <p:cNvPr id="42" name="TextBox 41"/>
+          <p:cNvPr id="51" name="TextBox 50"/>
           <p:cNvSpPr txBox="1"/>
           <p:nvPr/>
         </p:nvSpPr>
         <p:spPr>
           <a:xfrm>
-            <a:off x="10198100" y="2520950"/>
-            <a:ext cx="1492250" cy="508000"/>
+            <a:off x="6350000" y="4076700"/>
+            <a:ext cx="279400" cy="279400"/>
           </a:xfrm>
           <a:prstGeom prst="rect">
             <a:avLst/>
@@ -4785,55 +5213,125 @@
           <a:noFill/>
         </p:spPr>
         <p:txBody>
-          <a:bodyPr wrap="square" lIns="25400" rIns="25400" tIns="12700" bIns="12700" anchor="ctr">
-            <a:spAutoFit/>
+          <a:bodyPr wrap="square" anchor="ctr" lIns="0" rIns="0" tIns="0" bIns="0">
+            <a:noAutofit/>
           </a:bodyPr>
           <a:lstStyle/>
           <a:p>
-            <a:r>
-              <a:rPr sz="900" b="1">
+            <a:pPr algn="ctr">
+              <a:lnSpc>
+                <a:spcPct val="100000"/>
+              </a:lnSpc>
+            </a:pPr>
+            <a:r>
+              <a:rPr sz="1500" b="1">
+                <a:solidFill>
+                  <a:srgbClr val="FFFFFF"/>
+                </a:solidFill>
+                <a:latin typeface="Pretendard"/>
+              </a:rPr>
+              <a:t>④</a:t>
+            </a:r>
+          </a:p>
+        </p:txBody>
+      </p:sp>
+      <p:sp>
+        <p:nvSpPr>
+          <p:cNvPr id="52" name="TextBox 51"/>
+          <p:cNvSpPr txBox="1"/>
+          <p:nvPr/>
+        </p:nvSpPr>
+        <p:spPr>
+          <a:xfrm>
+            <a:off x="6756400" y="3987800"/>
+            <a:ext cx="2540000" cy="457200"/>
+          </a:xfrm>
+          <a:prstGeom prst="rect">
+            <a:avLst/>
+          </a:prstGeom>
+          <a:noFill/>
+        </p:spPr>
+        <p:txBody>
+          <a:bodyPr wrap="square" anchor="ctr" lIns="0" rIns="0" tIns="0" bIns="0">
+            <a:noAutofit/>
+          </a:bodyPr>
+          <a:lstStyle/>
+          <a:p>
+            <a:pPr algn="l">
+              <a:lnSpc>
+                <a:spcPct val="100000"/>
+              </a:lnSpc>
+            </a:pPr>
+            <a:r>
+              <a:rPr sz="1500" b="1">
+                <a:solidFill>
+                  <a:srgbClr val="141A3C"/>
+                </a:solidFill>
+                <a:latin typeface="Pretendard"/>
+              </a:rPr>
+              <a:t>짝 모의면접</a:t>
+            </a:r>
+          </a:p>
+        </p:txBody>
+      </p:sp>
+      <p:sp>
+        <p:nvSpPr>
+          <p:cNvPr id="53" name="TextBox 52"/>
+          <p:cNvSpPr txBox="1"/>
+          <p:nvPr/>
+        </p:nvSpPr>
+        <p:spPr>
+          <a:xfrm>
+            <a:off x="9334500" y="3987800"/>
+            <a:ext cx="2286000" cy="457200"/>
+          </a:xfrm>
+          <a:prstGeom prst="rect">
+            <a:avLst/>
+          </a:prstGeom>
+          <a:noFill/>
+        </p:spPr>
+        <p:txBody>
+          <a:bodyPr wrap="square" anchor="ctr" lIns="0" rIns="0" tIns="0" bIns="0">
+            <a:noAutofit/>
+          </a:bodyPr>
+          <a:lstStyle/>
+          <a:p>
+            <a:pPr algn="l">
+              <a:lnSpc>
+                <a:spcPct val="100000"/>
+              </a:lnSpc>
+            </a:pPr>
+            <a:r>
+              <a:rPr sz="1250" b="1">
                 <a:solidFill>
                   <a:srgbClr val="6C4CF5"/>
                 </a:solidFill>
                 <a:latin typeface="Pretendard"/>
               </a:rPr>
-              <a:t>산출물</a:t>
-            </a:r>
-          </a:p>
-          <a:p>
-            <a:r>
-              <a:rPr sz="1100" b="1">
-                <a:solidFill>
-                  <a:srgbClr val="141A3C"/>
-                </a:solidFill>
-                <a:latin typeface="Pretendard"/>
-              </a:rPr>
-              <a:t>프로젝트 설명 원고 · 근거·한계 점검표</a:t>
-            </a:r>
-          </a:p>
-        </p:txBody>
-      </p:sp>
-      <p:sp>
-        <p:nvSpPr>
-          <p:cNvPr id="43" name="Rectangle 42"/>
+              <a:t>2분 소개 · 예상 질문 5개</a:t>
+            </a:r>
+          </a:p>
+        </p:txBody>
+      </p:sp>
+      <p:sp>
+        <p:nvSpPr>
+          <p:cNvPr id="54" name="Rectangle 53"/>
           <p:cNvSpPr/>
           <p:nvPr/>
         </p:nvSpPr>
         <p:spPr>
           <a:xfrm>
-            <a:off x="6159500" y="3155950"/>
-            <a:ext cx="5651500" cy="635000"/>
+            <a:off x="508000" y="4775200"/>
+            <a:ext cx="3556000" cy="1765300"/>
           </a:xfrm>
           <a:prstGeom prst="rect">
             <a:avLst/>
           </a:prstGeom>
           <a:solidFill>
-            <a:srgbClr val="FFFFFF"/>
+            <a:srgbClr val="F3F5FA"/>
           </a:solidFill>
-          <a:ln w="9525">
-            <a:solidFill>
-              <a:srgbClr val="DDE1EE"/>
-            </a:solidFill>
+          <a:ln>
+            <a:noFill/>
           </a:ln>
           <a:effectLst/>
         </p:spPr>
@@ -4861,20 +5359,146 @@
       </p:sp>
       <p:sp>
         <p:nvSpPr>
-          <p:cNvPr id="44" name="Rectangle 43"/>
+          <p:cNvPr id="55" name="TextBox 54"/>
+          <p:cNvSpPr txBox="1"/>
+          <p:nvPr/>
+        </p:nvSpPr>
+        <p:spPr>
+          <a:xfrm>
+            <a:off x="685800" y="4927600"/>
+            <a:ext cx="3200400" cy="190500"/>
+          </a:xfrm>
+          <a:prstGeom prst="rect">
+            <a:avLst/>
+          </a:prstGeom>
+          <a:noFill/>
+        </p:spPr>
+        <p:txBody>
+          <a:bodyPr wrap="square" anchor="t" lIns="0" rIns="0" tIns="0" bIns="0">
+            <a:noAutofit/>
+          </a:bodyPr>
+          <a:lstStyle/>
+          <a:p>
+            <a:pPr algn="l">
+              <a:lnSpc>
+                <a:spcPct val="115000"/>
+              </a:lnSpc>
+            </a:pPr>
+            <a:r>
+              <a:rPr sz="1400" b="1">
+                <a:solidFill>
+                  <a:srgbClr val="0E9F7A"/>
+                </a:solidFill>
+                <a:latin typeface="Pretendard"/>
+              </a:rPr>
+              <a:t>평가 기준</a:t>
+            </a:r>
+          </a:p>
+        </p:txBody>
+      </p:sp>
+      <p:sp>
+        <p:nvSpPr>
+          <p:cNvPr id="56" name="TextBox 55"/>
+          <p:cNvSpPr txBox="1"/>
+          <p:nvPr/>
+        </p:nvSpPr>
+        <p:spPr>
+          <a:xfrm>
+            <a:off x="685800" y="5156200"/>
+            <a:ext cx="3200400" cy="1257300"/>
+          </a:xfrm>
+          <a:prstGeom prst="rect">
+            <a:avLst/>
+          </a:prstGeom>
+          <a:noFill/>
+        </p:spPr>
+        <p:txBody>
+          <a:bodyPr wrap="square" anchor="t" lIns="0" rIns="0" tIns="0" bIns="0">
+            <a:noAutofit/>
+          </a:bodyPr>
+          <a:lstStyle/>
+          <a:p>
+            <a:pPr algn="l">
+              <a:lnSpc>
+                <a:spcPct val="125000"/>
+              </a:lnSpc>
+            </a:pPr>
+            <a:r>
+              <a:rPr sz="1250" b="0">
+                <a:solidFill>
+                  <a:srgbClr val="4A5070"/>
+                </a:solidFill>
+                <a:latin typeface="Pretendard"/>
+              </a:rPr>
+              <a:t>•  직무 연결성</a:t>
+            </a:r>
+          </a:p>
+          <a:p>
+            <a:pPr algn="l">
+              <a:lnSpc>
+                <a:spcPct val="125000"/>
+              </a:lnSpc>
+            </a:pPr>
+            <a:r>
+              <a:rPr sz="1250" b="0">
+                <a:solidFill>
+                  <a:srgbClr val="4A5070"/>
+                </a:solidFill>
+                <a:latin typeface="Pretendard"/>
+              </a:rPr>
+              <a:t>•  본인 기여의 명확성</a:t>
+            </a:r>
+          </a:p>
+          <a:p>
+            <a:pPr algn="l">
+              <a:lnSpc>
+                <a:spcPct val="125000"/>
+              </a:lnSpc>
+            </a:pPr>
+            <a:r>
+              <a:rPr sz="1250" b="0">
+                <a:solidFill>
+                  <a:srgbClr val="4A5070"/>
+                </a:solidFill>
+                <a:latin typeface="Pretendard"/>
+              </a:rPr>
+              <a:t>•  결과 근거 · 한계 설명</a:t>
+            </a:r>
+          </a:p>
+          <a:p>
+            <a:pPr algn="l">
+              <a:lnSpc>
+                <a:spcPct val="125000"/>
+              </a:lnSpc>
+            </a:pPr>
+            <a:r>
+              <a:rPr sz="1250" b="0">
+                <a:solidFill>
+                  <a:srgbClr val="4A5070"/>
+                </a:solidFill>
+                <a:latin typeface="Pretendard"/>
+              </a:rPr>
+              <a:t>•  문서·발표의 일관성</a:t>
+            </a:r>
+          </a:p>
+        </p:txBody>
+      </p:sp>
+      <p:sp>
+        <p:nvSpPr>
+          <p:cNvPr id="57" name="Rectangle 56"/>
           <p:cNvSpPr/>
           <p:nvPr/>
         </p:nvSpPr>
         <p:spPr>
           <a:xfrm>
-            <a:off x="6159500" y="3155950"/>
-            <a:ext cx="50800" cy="635000"/>
+            <a:off x="4318000" y="4775200"/>
+            <a:ext cx="3556000" cy="1765300"/>
           </a:xfrm>
           <a:prstGeom prst="rect">
             <a:avLst/>
           </a:prstGeom>
           <a:solidFill>
-            <a:srgbClr val="6C4CF5"/>
+            <a:srgbClr val="F3F5FA"/>
           </a:solidFill>
           <a:ln>
             <a:noFill/>
@@ -4905,14 +5529,14 @@
       </p:sp>
       <p:sp>
         <p:nvSpPr>
-          <p:cNvPr id="45" name="TextBox 44"/>
+          <p:cNvPr id="58" name="TextBox 57"/>
           <p:cNvSpPr txBox="1"/>
           <p:nvPr/>
         </p:nvSpPr>
         <p:spPr>
           <a:xfrm>
-            <a:off x="6286500" y="3206750"/>
-            <a:ext cx="825500" cy="571500"/>
+            <a:off x="4495800" y="4927600"/>
+            <a:ext cx="3200400" cy="190500"/>
           </a:xfrm>
           <a:prstGeom prst="rect">
             <a:avLst/>
@@ -4920,44 +5544,38 @@
           <a:noFill/>
         </p:spPr>
         <p:txBody>
-          <a:bodyPr wrap="square" lIns="25400" rIns="25400" tIns="12700" bIns="12700" anchor="ctr">
-            <a:spAutoFit/>
+          <a:bodyPr wrap="square" anchor="t" lIns="0" rIns="0" tIns="0" bIns="0">
+            <a:noAutofit/>
           </a:bodyPr>
           <a:lstStyle/>
           <a:p>
-            <a:r>
-              <a:rPr sz="1300" b="1">
-                <a:solidFill>
-                  <a:srgbClr val="141A3C"/>
-                </a:solidFill>
-                <a:latin typeface="Pretendard"/>
-              </a:rPr>
-              <a:t>2회기 ②</a:t>
-            </a:r>
-          </a:p>
-          <a:p>
-            <a:r>
-              <a:rPr sz="1100" b="0">
-                <a:solidFill>
-                  <a:srgbClr val="4A5070"/>
-                </a:solidFill>
-                <a:latin typeface="Pretendard"/>
-              </a:rPr>
-              <a:t>2시간</a:t>
-            </a:r>
-          </a:p>
-        </p:txBody>
-      </p:sp>
-      <p:sp>
-        <p:nvSpPr>
-          <p:cNvPr id="46" name="TextBox 45"/>
+            <a:pPr algn="l">
+              <a:lnSpc>
+                <a:spcPct val="115000"/>
+              </a:lnSpc>
+            </a:pPr>
+            <a:r>
+              <a:rPr sz="1400" b="1">
+                <a:solidFill>
+                  <a:srgbClr val="0E9F7A"/>
+                </a:solidFill>
+                <a:latin typeface="Pretendard"/>
+              </a:rPr>
+              <a:t>지도 원칙</a:t>
+            </a:r>
+          </a:p>
+        </p:txBody>
+      </p:sp>
+      <p:sp>
+        <p:nvSpPr>
+          <p:cNvPr id="59" name="TextBox 58"/>
           <p:cNvSpPr txBox="1"/>
           <p:nvPr/>
         </p:nvSpPr>
         <p:spPr>
           <a:xfrm>
-            <a:off x="7112000" y="3206750"/>
-            <a:ext cx="2984500" cy="584200"/>
+            <a:off x="4495800" y="5156200"/>
+            <a:ext cx="3200400" cy="1257300"/>
           </a:xfrm>
           <a:prstGeom prst="rect">
             <a:avLst/>
@@ -4965,33 +5583,86 @@
           <a:noFill/>
         </p:spPr>
         <p:txBody>
-          <a:bodyPr wrap="square" lIns="25400" rIns="25400" tIns="12700" bIns="12700" anchor="ctr">
-            <a:spAutoFit/>
+          <a:bodyPr wrap="square" anchor="t" lIns="0" rIns="0" tIns="0" bIns="0">
+            <a:noAutofit/>
           </a:bodyPr>
           <a:lstStyle/>
           <a:p>
-            <a:r>
-              <a:rPr sz="1100" b="0">
+            <a:pPr algn="l">
+              <a:lnSpc>
+                <a:spcPct val="125000"/>
+              </a:lnSpc>
+            </a:pPr>
+            <a:r>
+              <a:rPr sz="1250" b="0">
                 <a:solidFill>
                   <a:srgbClr val="4A5070"/>
                 </a:solidFill>
                 <a:latin typeface="Pretendard"/>
               </a:rPr>
-              <a:t>[도구 3]으로 소개 페이지 구성, AI로 가독성 개선. 본인 기여와 팀 성과를 구분해 반영.</a:t>
-            </a:r>
-          </a:p>
-        </p:txBody>
-      </p:sp>
-      <p:sp>
-        <p:nvSpPr>
-          <p:cNvPr id="47" name="Rectangle 46"/>
+              <a:t>•  개인정보·기밀 제외</a:t>
+            </a:r>
+          </a:p>
+          <a:p>
+            <a:pPr algn="l">
+              <a:lnSpc>
+                <a:spcPct val="125000"/>
+              </a:lnSpc>
+            </a:pPr>
+            <a:r>
+              <a:rPr sz="1250" b="0">
+                <a:solidFill>
+                  <a:srgbClr val="4A5070"/>
+                </a:solidFill>
+                <a:latin typeface="Pretendard"/>
+              </a:rPr>
+              <a:t>•  경험·성과 창작 금지</a:t>
+            </a:r>
+          </a:p>
+          <a:p>
+            <a:pPr algn="l">
+              <a:lnSpc>
+                <a:spcPct val="125000"/>
+              </a:lnSpc>
+            </a:pPr>
+            <a:r>
+              <a:rPr sz="1250" b="0">
+                <a:solidFill>
+                  <a:srgbClr val="4A5070"/>
+                </a:solidFill>
+                <a:latin typeface="Pretendard"/>
+              </a:rPr>
+              <a:t>•  AI 출력은 본인이 근거 확인</a:t>
+            </a:r>
+          </a:p>
+          <a:p>
+            <a:pPr algn="l">
+              <a:lnSpc>
+                <a:spcPct val="125000"/>
+              </a:lnSpc>
+            </a:pPr>
+            <a:r>
+              <a:rPr sz="1250" b="0">
+                <a:solidFill>
+                  <a:srgbClr val="4A5070"/>
+                </a:solidFill>
+                <a:latin typeface="Pretendard"/>
+              </a:rPr>
+              <a:t>•  코드·모델 검증은 기술 멘토 범위</a:t>
+            </a:r>
+          </a:p>
+        </p:txBody>
+      </p:sp>
+      <p:sp>
+        <p:nvSpPr>
+          <p:cNvPr id="60" name="Rectangle 59"/>
           <p:cNvSpPr/>
           <p:nvPr/>
         </p:nvSpPr>
         <p:spPr>
           <a:xfrm>
-            <a:off x="10160000" y="3219450"/>
-            <a:ext cx="1555750" cy="508000"/>
+            <a:off x="8128000" y="4775200"/>
+            <a:ext cx="3556000" cy="1765300"/>
           </a:xfrm>
           <a:prstGeom prst="rect">
             <a:avLst/>
@@ -5028,14 +5699,14 @@
       </p:sp>
       <p:sp>
         <p:nvSpPr>
-          <p:cNvPr id="48" name="TextBox 47"/>
+          <p:cNvPr id="61" name="TextBox 60"/>
           <p:cNvSpPr txBox="1"/>
           <p:nvPr/>
         </p:nvSpPr>
         <p:spPr>
           <a:xfrm>
-            <a:off x="10198100" y="3219450"/>
-            <a:ext cx="1492250" cy="508000"/>
+            <a:off x="8305800" y="4927600"/>
+            <a:ext cx="3200400" cy="190500"/>
           </a:xfrm>
           <a:prstGeom prst="rect">
             <a:avLst/>
@@ -5043,591 +5714,25 @@
           <a:noFill/>
         </p:spPr>
         <p:txBody>
-          <a:bodyPr wrap="square" lIns="25400" rIns="25400" tIns="12700" bIns="12700" anchor="ctr">
-            <a:spAutoFit/>
+          <a:bodyPr wrap="square" anchor="t" lIns="0" rIns="0" tIns="0" bIns="0">
+            <a:noAutofit/>
           </a:bodyPr>
           <a:lstStyle/>
           <a:p>
-            <a:r>
-              <a:rPr sz="900" b="1">
-                <a:solidFill>
-                  <a:srgbClr val="6C4CF5"/>
-                </a:solidFill>
-                <a:latin typeface="Pretendard"/>
-              </a:rPr>
-              <a:t>산출물</a:t>
-            </a:r>
-          </a:p>
-          <a:p>
-            <a:r>
-              <a:rPr sz="1100" b="1">
-                <a:solidFill>
-                  <a:srgbClr val="141A3C"/>
-                </a:solidFill>
-                <a:latin typeface="Pretendard"/>
-              </a:rPr>
-              <a:t>포트폴리오 소개 1쪽 수정본</a:t>
-            </a:r>
-          </a:p>
-        </p:txBody>
-      </p:sp>
-      <p:sp>
-        <p:nvSpPr>
-          <p:cNvPr id="49" name="Rectangle 48"/>
-          <p:cNvSpPr/>
-          <p:nvPr/>
-        </p:nvSpPr>
-        <p:spPr>
-          <a:xfrm>
-            <a:off x="6159500" y="3854450"/>
-            <a:ext cx="5651500" cy="635000"/>
-          </a:xfrm>
-          <a:prstGeom prst="rect">
-            <a:avLst/>
-          </a:prstGeom>
-          <a:solidFill>
-            <a:srgbClr val="FFFFFF"/>
-          </a:solidFill>
-          <a:ln w="9525">
-            <a:solidFill>
-              <a:srgbClr val="DDE1EE"/>
-            </a:solidFill>
-          </a:ln>
-          <a:effectLst/>
-        </p:spPr>
-        <p:style>
-          <a:lnRef idx="1">
-            <a:schemeClr val="accent1"/>
-          </a:lnRef>
-          <a:fillRef idx="3">
-            <a:schemeClr val="accent1"/>
-          </a:fillRef>
-          <a:effectRef idx="2">
-            <a:schemeClr val="accent1"/>
-          </a:effectRef>
-          <a:fontRef idx="minor">
-            <a:schemeClr val="lt1"/>
-          </a:fontRef>
-        </p:style>
-        <p:txBody>
-          <a:bodyPr rtlCol="0" anchor="ctr"/>
-          <a:lstStyle/>
-          <a:p>
-            <a:pPr algn="ctr"/>
-          </a:p>
-        </p:txBody>
-      </p:sp>
-      <p:sp>
-        <p:nvSpPr>
-          <p:cNvPr id="50" name="Rectangle 49"/>
-          <p:cNvSpPr/>
-          <p:nvPr/>
-        </p:nvSpPr>
-        <p:spPr>
-          <a:xfrm>
-            <a:off x="6159500" y="3854450"/>
-            <a:ext cx="50800" cy="635000"/>
-          </a:xfrm>
-          <a:prstGeom prst="rect">
-            <a:avLst/>
-          </a:prstGeom>
-          <a:solidFill>
-            <a:srgbClr val="6C4CF5"/>
-          </a:solidFill>
-          <a:ln>
-            <a:noFill/>
-          </a:ln>
-          <a:effectLst/>
-        </p:spPr>
-        <p:style>
-          <a:lnRef idx="1">
-            <a:schemeClr val="accent1"/>
-          </a:lnRef>
-          <a:fillRef idx="3">
-            <a:schemeClr val="accent1"/>
-          </a:fillRef>
-          <a:effectRef idx="2">
-            <a:schemeClr val="accent1"/>
-          </a:effectRef>
-          <a:fontRef idx="minor">
-            <a:schemeClr val="lt1"/>
-          </a:fontRef>
-        </p:style>
-        <p:txBody>
-          <a:bodyPr rtlCol="0" anchor="ctr"/>
-          <a:lstStyle/>
-          <a:p>
-            <a:pPr algn="ctr"/>
-          </a:p>
-        </p:txBody>
-      </p:sp>
-      <p:sp>
-        <p:nvSpPr>
-          <p:cNvPr id="51" name="TextBox 50"/>
-          <p:cNvSpPr txBox="1"/>
-          <p:nvPr/>
-        </p:nvSpPr>
-        <p:spPr>
-          <a:xfrm>
-            <a:off x="6286500" y="3905250"/>
-            <a:ext cx="825500" cy="571500"/>
-          </a:xfrm>
-          <a:prstGeom prst="rect">
-            <a:avLst/>
-          </a:prstGeom>
-          <a:noFill/>
-        </p:spPr>
-        <p:txBody>
-          <a:bodyPr wrap="square" lIns="25400" rIns="25400" tIns="12700" bIns="12700" anchor="ctr">
-            <a:spAutoFit/>
-          </a:bodyPr>
-          <a:lstStyle/>
-          <a:p>
-            <a:r>
-              <a:rPr sz="1300" b="1">
-                <a:solidFill>
-                  <a:srgbClr val="141A3C"/>
-                </a:solidFill>
-                <a:latin typeface="Pretendard"/>
-              </a:rPr>
-              <a:t>2회기 ③</a:t>
-            </a:r>
-          </a:p>
-          <a:p>
-            <a:r>
-              <a:rPr sz="1100" b="0">
-                <a:solidFill>
-                  <a:srgbClr val="4A5070"/>
-                </a:solidFill>
-                <a:latin typeface="Pretendard"/>
-              </a:rPr>
-              <a:t>2시간</a:t>
-            </a:r>
-          </a:p>
-        </p:txBody>
-      </p:sp>
-      <p:sp>
-        <p:nvSpPr>
-          <p:cNvPr id="52" name="TextBox 51"/>
-          <p:cNvSpPr txBox="1"/>
-          <p:nvPr/>
-        </p:nvSpPr>
-        <p:spPr>
-          <a:xfrm>
-            <a:off x="7112000" y="3905250"/>
-            <a:ext cx="2984500" cy="584200"/>
-          </a:xfrm>
-          <a:prstGeom prst="rect">
-            <a:avLst/>
-          </a:prstGeom>
-          <a:noFill/>
-        </p:spPr>
-        <p:txBody>
-          <a:bodyPr wrap="square" lIns="25400" rIns="25400" tIns="12700" bIns="12700" anchor="ctr">
-            <a:spAutoFit/>
-          </a:bodyPr>
-          <a:lstStyle/>
-          <a:p>
-            <a:r>
-              <a:rPr sz="1100" b="0">
-                <a:solidFill>
-                  <a:srgbClr val="4A5070"/>
-                </a:solidFill>
-                <a:latin typeface="Pretendard"/>
-              </a:rPr>
-              <a:t>별도 AI 실습으로 GitHub README 작성. 사용 방법·평가 조건·링크 확인, 포트폴리오와 대조.</a:t>
-            </a:r>
-          </a:p>
-        </p:txBody>
-      </p:sp>
-      <p:sp>
-        <p:nvSpPr>
-          <p:cNvPr id="53" name="Rectangle 52"/>
-          <p:cNvSpPr/>
-          <p:nvPr/>
-        </p:nvSpPr>
-        <p:spPr>
-          <a:xfrm>
-            <a:off x="10160000" y="3917950"/>
-            <a:ext cx="1555750" cy="508000"/>
-          </a:xfrm>
-          <a:prstGeom prst="rect">
-            <a:avLst/>
-          </a:prstGeom>
-          <a:solidFill>
-            <a:srgbClr val="F3F5FA"/>
-          </a:solidFill>
-          <a:ln>
-            <a:noFill/>
-          </a:ln>
-          <a:effectLst/>
-        </p:spPr>
-        <p:style>
-          <a:lnRef idx="1">
-            <a:schemeClr val="accent1"/>
-          </a:lnRef>
-          <a:fillRef idx="3">
-            <a:schemeClr val="accent1"/>
-          </a:fillRef>
-          <a:effectRef idx="2">
-            <a:schemeClr val="accent1"/>
-          </a:effectRef>
-          <a:fontRef idx="minor">
-            <a:schemeClr val="lt1"/>
-          </a:fontRef>
-        </p:style>
-        <p:txBody>
-          <a:bodyPr rtlCol="0" anchor="ctr"/>
-          <a:lstStyle/>
-          <a:p>
-            <a:pPr algn="ctr"/>
-          </a:p>
-        </p:txBody>
-      </p:sp>
-      <p:sp>
-        <p:nvSpPr>
-          <p:cNvPr id="54" name="TextBox 53"/>
-          <p:cNvSpPr txBox="1"/>
-          <p:nvPr/>
-        </p:nvSpPr>
-        <p:spPr>
-          <a:xfrm>
-            <a:off x="10198100" y="3917950"/>
-            <a:ext cx="1492250" cy="508000"/>
-          </a:xfrm>
-          <a:prstGeom prst="rect">
-            <a:avLst/>
-          </a:prstGeom>
-          <a:noFill/>
-        </p:spPr>
-        <p:txBody>
-          <a:bodyPr wrap="square" lIns="25400" rIns="25400" tIns="12700" bIns="12700" anchor="ctr">
-            <a:spAutoFit/>
-          </a:bodyPr>
-          <a:lstStyle/>
-          <a:p>
-            <a:r>
-              <a:rPr sz="900" b="1">
-                <a:solidFill>
-                  <a:srgbClr val="6C4CF5"/>
-                </a:solidFill>
-                <a:latin typeface="Pretendard"/>
-              </a:rPr>
-              <a:t>산출물</a:t>
-            </a:r>
-          </a:p>
-          <a:p>
-            <a:r>
-              <a:rPr sz="1100" b="1">
-                <a:solidFill>
-                  <a:srgbClr val="141A3C"/>
-                </a:solidFill>
-                <a:latin typeface="Pretendard"/>
-              </a:rPr>
-              <a:t>README 작성본 · 문서 일관성 체크</a:t>
-            </a:r>
-          </a:p>
-        </p:txBody>
-      </p:sp>
-      <p:sp>
-        <p:nvSpPr>
-          <p:cNvPr id="55" name="Rectangle 54"/>
-          <p:cNvSpPr/>
-          <p:nvPr/>
-        </p:nvSpPr>
-        <p:spPr>
-          <a:xfrm>
-            <a:off x="6159500" y="4552950"/>
-            <a:ext cx="5651500" cy="635000"/>
-          </a:xfrm>
-          <a:prstGeom prst="rect">
-            <a:avLst/>
-          </a:prstGeom>
-          <a:solidFill>
-            <a:srgbClr val="FFFFFF"/>
-          </a:solidFill>
-          <a:ln w="9525">
-            <a:solidFill>
-              <a:srgbClr val="DDE1EE"/>
-            </a:solidFill>
-          </a:ln>
-          <a:effectLst/>
-        </p:spPr>
-        <p:style>
-          <a:lnRef idx="1">
-            <a:schemeClr val="accent1"/>
-          </a:lnRef>
-          <a:fillRef idx="3">
-            <a:schemeClr val="accent1"/>
-          </a:fillRef>
-          <a:effectRef idx="2">
-            <a:schemeClr val="accent1"/>
-          </a:effectRef>
-          <a:fontRef idx="minor">
-            <a:schemeClr val="lt1"/>
-          </a:fontRef>
-        </p:style>
-        <p:txBody>
-          <a:bodyPr rtlCol="0" anchor="ctr"/>
-          <a:lstStyle/>
-          <a:p>
-            <a:pPr algn="ctr"/>
-          </a:p>
-        </p:txBody>
-      </p:sp>
-      <p:sp>
-        <p:nvSpPr>
-          <p:cNvPr id="56" name="Rectangle 55"/>
-          <p:cNvSpPr/>
-          <p:nvPr/>
-        </p:nvSpPr>
-        <p:spPr>
-          <a:xfrm>
-            <a:off x="6159500" y="4552950"/>
-            <a:ext cx="50800" cy="635000"/>
-          </a:xfrm>
-          <a:prstGeom prst="rect">
-            <a:avLst/>
-          </a:prstGeom>
-          <a:solidFill>
-            <a:srgbClr val="6C4CF5"/>
-          </a:solidFill>
-          <a:ln>
-            <a:noFill/>
-          </a:ln>
-          <a:effectLst/>
-        </p:spPr>
-        <p:style>
-          <a:lnRef idx="1">
-            <a:schemeClr val="accent1"/>
-          </a:lnRef>
-          <a:fillRef idx="3">
-            <a:schemeClr val="accent1"/>
-          </a:fillRef>
-          <a:effectRef idx="2">
-            <a:schemeClr val="accent1"/>
-          </a:effectRef>
-          <a:fontRef idx="minor">
-            <a:schemeClr val="lt1"/>
-          </a:fontRef>
-        </p:style>
-        <p:txBody>
-          <a:bodyPr rtlCol="0" anchor="ctr"/>
-          <a:lstStyle/>
-          <a:p>
-            <a:pPr algn="ctr"/>
-          </a:p>
-        </p:txBody>
-      </p:sp>
-      <p:sp>
-        <p:nvSpPr>
-          <p:cNvPr id="57" name="TextBox 56"/>
-          <p:cNvSpPr txBox="1"/>
-          <p:nvPr/>
-        </p:nvSpPr>
-        <p:spPr>
-          <a:xfrm>
-            <a:off x="6286500" y="4603750"/>
-            <a:ext cx="825500" cy="571500"/>
-          </a:xfrm>
-          <a:prstGeom prst="rect">
-            <a:avLst/>
-          </a:prstGeom>
-          <a:noFill/>
-        </p:spPr>
-        <p:txBody>
-          <a:bodyPr wrap="square" lIns="25400" rIns="25400" tIns="12700" bIns="12700" anchor="ctr">
-            <a:spAutoFit/>
-          </a:bodyPr>
-          <a:lstStyle/>
-          <a:p>
-            <a:r>
-              <a:rPr sz="1300" b="1">
-                <a:solidFill>
-                  <a:srgbClr val="141A3C"/>
-                </a:solidFill>
-                <a:latin typeface="Pretendard"/>
-              </a:rPr>
-              <a:t>2회기 ④</a:t>
-            </a:r>
-          </a:p>
-          <a:p>
-            <a:r>
-              <a:rPr sz="1100" b="0">
-                <a:solidFill>
-                  <a:srgbClr val="4A5070"/>
-                </a:solidFill>
-                <a:latin typeface="Pretendard"/>
-              </a:rPr>
-              <a:t>2시간</a:t>
-            </a:r>
-          </a:p>
-        </p:txBody>
-      </p:sp>
-      <p:sp>
-        <p:nvSpPr>
-          <p:cNvPr id="58" name="TextBox 57"/>
-          <p:cNvSpPr txBox="1"/>
-          <p:nvPr/>
-        </p:nvSpPr>
-        <p:spPr>
-          <a:xfrm>
-            <a:off x="7112000" y="4603750"/>
-            <a:ext cx="2984500" cy="584200"/>
-          </a:xfrm>
-          <a:prstGeom prst="rect">
-            <a:avLst/>
-          </a:prstGeom>
-          <a:noFill/>
-        </p:spPr>
-        <p:txBody>
-          <a:bodyPr wrap="square" lIns="25400" rIns="25400" tIns="12700" bIns="12700" anchor="ctr">
-            <a:spAutoFit/>
-          </a:bodyPr>
-          <a:lstStyle/>
-          <a:p>
-            <a:r>
-              <a:rPr sz="1100" b="0">
-                <a:solidFill>
-                  <a:srgbClr val="4A5070"/>
-                </a:solidFill>
-                <a:latin typeface="Pretendard"/>
-              </a:rPr>
-              <a:t>AI로 예상 질문·답변 피드백 생성, 짝 모의면접. 사실·기술 선택 이유를 설명하고 수정.</a:t>
-            </a:r>
-          </a:p>
-        </p:txBody>
-      </p:sp>
-      <p:sp>
-        <p:nvSpPr>
-          <p:cNvPr id="59" name="Rectangle 58"/>
-          <p:cNvSpPr/>
-          <p:nvPr/>
-        </p:nvSpPr>
-        <p:spPr>
-          <a:xfrm>
-            <a:off x="10160000" y="4616450"/>
-            <a:ext cx="1555750" cy="508000"/>
-          </a:xfrm>
-          <a:prstGeom prst="rect">
-            <a:avLst/>
-          </a:prstGeom>
-          <a:solidFill>
-            <a:srgbClr val="F3F5FA"/>
-          </a:solidFill>
-          <a:ln>
-            <a:noFill/>
-          </a:ln>
-          <a:effectLst/>
-        </p:spPr>
-        <p:style>
-          <a:lnRef idx="1">
-            <a:schemeClr val="accent1"/>
-          </a:lnRef>
-          <a:fillRef idx="3">
-            <a:schemeClr val="accent1"/>
-          </a:fillRef>
-          <a:effectRef idx="2">
-            <a:schemeClr val="accent1"/>
-          </a:effectRef>
-          <a:fontRef idx="minor">
-            <a:schemeClr val="lt1"/>
-          </a:fontRef>
-        </p:style>
-        <p:txBody>
-          <a:bodyPr rtlCol="0" anchor="ctr"/>
-          <a:lstStyle/>
-          <a:p>
-            <a:pPr algn="ctr"/>
-          </a:p>
-        </p:txBody>
-      </p:sp>
-      <p:sp>
-        <p:nvSpPr>
-          <p:cNvPr id="60" name="TextBox 59"/>
-          <p:cNvSpPr txBox="1"/>
-          <p:nvPr/>
-        </p:nvSpPr>
-        <p:spPr>
-          <a:xfrm>
-            <a:off x="10198100" y="4616450"/>
-            <a:ext cx="1492250" cy="508000"/>
-          </a:xfrm>
-          <a:prstGeom prst="rect">
-            <a:avLst/>
-          </a:prstGeom>
-          <a:noFill/>
-        </p:spPr>
-        <p:txBody>
-          <a:bodyPr wrap="square" lIns="25400" rIns="25400" tIns="12700" bIns="12700" anchor="ctr">
-            <a:spAutoFit/>
-          </a:bodyPr>
-          <a:lstStyle/>
-          <a:p>
-            <a:r>
-              <a:rPr sz="900" b="1">
-                <a:solidFill>
-                  <a:srgbClr val="6C4CF5"/>
-                </a:solidFill>
-                <a:latin typeface="Pretendard"/>
-              </a:rPr>
-              <a:t>산출물</a:t>
-            </a:r>
-          </a:p>
-          <a:p>
-            <a:r>
-              <a:rPr sz="1100" b="1">
-                <a:solidFill>
-                  <a:srgbClr val="141A3C"/>
-                </a:solidFill>
-                <a:latin typeface="Pretendard"/>
-              </a:rPr>
-              <a:t>2분 소개·질문 5개 · 답변 개선 목록</a:t>
-            </a:r>
-          </a:p>
-        </p:txBody>
-      </p:sp>
-      <p:sp>
-        <p:nvSpPr>
-          <p:cNvPr id="61" name="Rectangle 60"/>
-          <p:cNvSpPr/>
-          <p:nvPr/>
-        </p:nvSpPr>
-        <p:spPr>
-          <a:xfrm>
-            <a:off x="381000" y="5270500"/>
-            <a:ext cx="11430000" cy="1301750"/>
-          </a:xfrm>
-          <a:prstGeom prst="rect">
-            <a:avLst/>
-          </a:prstGeom>
-          <a:solidFill>
-            <a:srgbClr val="F3F5FA"/>
-          </a:solidFill>
-          <a:ln>
-            <a:noFill/>
-          </a:ln>
-          <a:effectLst/>
-        </p:spPr>
-        <p:style>
-          <a:lnRef idx="1">
-            <a:schemeClr val="accent1"/>
-          </a:lnRef>
-          <a:fillRef idx="3">
-            <a:schemeClr val="accent1"/>
-          </a:fillRef>
-          <a:effectRef idx="2">
-            <a:schemeClr val="accent1"/>
-          </a:effectRef>
-          <a:fontRef idx="minor">
-            <a:schemeClr val="lt1"/>
-          </a:fontRef>
-        </p:style>
-        <p:txBody>
-          <a:bodyPr rtlCol="0" anchor="ctr"/>
-          <a:lstStyle/>
-          <a:p>
-            <a:pPr algn="ctr"/>
+            <a:pPr algn="l">
+              <a:lnSpc>
+                <a:spcPct val="115000"/>
+              </a:lnSpc>
+            </a:pPr>
+            <a:r>
+              <a:rPr sz="1400" b="1">
+                <a:solidFill>
+                  <a:srgbClr val="0E9F7A"/>
+                </a:solidFill>
+                <a:latin typeface="Pretendard"/>
+              </a:rPr>
+              <a:t>실습 도구 · 참고 자료</a:t>
+            </a:r>
           </a:p>
         </p:txBody>
       </p:sp>
@@ -5639,8 +5744,8 @@
         </p:nvSpPr>
         <p:spPr>
           <a:xfrm>
-            <a:off x="508000" y="5334000"/>
-            <a:ext cx="7112000" cy="1206500"/>
+            <a:off x="8305800" y="5156200"/>
+            <a:ext cx="3200400" cy="1257300"/>
           </a:xfrm>
           <a:prstGeom prst="rect">
             <a:avLst/>
@@ -5648,88 +5753,164 @@
           <a:noFill/>
         </p:spPr>
         <p:txBody>
-          <a:bodyPr wrap="square" lIns="25400" rIns="25400" tIns="12700" bIns="12700">
-            <a:spAutoFit/>
+          <a:bodyPr wrap="square" anchor="t" lIns="0" rIns="0" tIns="0" bIns="0">
+            <a:noAutofit/>
           </a:bodyPr>
           <a:lstStyle/>
           <a:p>
-            <a:r>
-              <a:rPr sz="1100" b="1">
-                <a:solidFill>
-                  <a:srgbClr val="10A37F"/>
-                </a:solidFill>
-                <a:latin typeface="Pretendard"/>
-              </a:rPr>
-              <a:t>사전 준비  </a:t>
-            </a:r>
-            <a:r>
-              <a:rPr sz="1050" b="0">
+            <a:pPr algn="l">
+              <a:lnSpc>
+                <a:spcPct val="125000"/>
+              </a:lnSpc>
+            </a:pPr>
+            <a:r>
+              <a:rPr sz="1250" b="0">
                 <a:solidFill>
                   <a:srgbClr val="4A5070"/>
                 </a:solidFill>
                 <a:latin typeface="Pretendard"/>
               </a:rPr>
-              <a:t>노트북·채용공고·프로젝트 자료·이력서. AI API 이용 조건·비용·전송/저장 동의 확인, 연결 장애 시 워크시트·강사 시연으로 진행</a:t>
-            </a:r>
-          </a:p>
-          <a:p>
-            <a:r>
-              <a:rPr sz="1100" b="1">
-                <a:solidFill>
-                  <a:srgbClr val="10A37F"/>
-                </a:solidFill>
-                <a:latin typeface="Pretendard"/>
-              </a:rPr>
-              <a:t>평가 기준  </a:t>
-            </a:r>
-            <a:r>
-              <a:rPr sz="1050" b="0">
+              <a:t>•  </a:t>
+            </a:r>
+            <a:r>
+              <a:rPr sz="1250" b="0" u="sng">
+                <a:solidFill>
+                  <a:srgbClr val="2F5BD8"/>
+                </a:solidFill>
+                <a:latin typeface="Pretendard"/>
+                <a:hlinkClick r:id="rId2"/>
+              </a:rPr>
+              <a:t>도구 1  기업·경험 찾기</a:t>
+            </a:r>
+          </a:p>
+          <a:p>
+            <a:pPr algn="l">
+              <a:lnSpc>
+                <a:spcPct val="125000"/>
+              </a:lnSpc>
+            </a:pPr>
+            <a:r>
+              <a:rPr sz="1250" b="0">
                 <a:solidFill>
                   <a:srgbClr val="4A5070"/>
                 </a:solidFill>
                 <a:latin typeface="Pretendard"/>
               </a:rPr>
-              <a:t>직무 연결성 / 본인 기여의 명확성 / 결과 근거 / 한계 설명 / 문서·발표의 일관성</a:t>
-            </a:r>
-          </a:p>
-          <a:p>
-            <a:r>
-              <a:rPr sz="1100" b="1">
-                <a:solidFill>
-                  <a:srgbClr val="10A37F"/>
-                </a:solidFill>
-                <a:latin typeface="Pretendard"/>
-              </a:rPr>
-              <a:t>지도 원칙  </a:t>
-            </a:r>
-            <a:r>
-              <a:rPr sz="1050" b="0">
+              <a:t>•  </a:t>
+            </a:r>
+            <a:r>
+              <a:rPr sz="1250" b="0" u="sng">
+                <a:solidFill>
+                  <a:srgbClr val="2F5BD8"/>
+                </a:solidFill>
+                <a:latin typeface="Pretendard"/>
+                <a:hlinkClick r:id="rId3"/>
+              </a:rPr>
+              <a:t>도구 2  AI 자기소개서</a:t>
+            </a:r>
+          </a:p>
+          <a:p>
+            <a:pPr algn="l">
+              <a:lnSpc>
+                <a:spcPct val="125000"/>
+              </a:lnSpc>
+            </a:pPr>
+            <a:r>
+              <a:rPr sz="1250" b="0">
                 <a:solidFill>
                   <a:srgbClr val="4A5070"/>
                 </a:solidFill>
                 <a:latin typeface="Pretendard"/>
               </a:rPr>
-              <a:t>개인정보·기밀 제외, 경험·성과 창작 금지, AI 출력은 본인이 근거 확인. 코드·모델 성능 검증은 기술 멘토 별도 범위</a:t>
-            </a:r>
-          </a:p>
-          <a:p>
-            <a:r>
-              <a:rPr sz="1100" b="1">
-                <a:solidFill>
-                  <a:srgbClr val="10A37F"/>
-                </a:solidFill>
-                <a:latin typeface="Pretendard"/>
-              </a:rPr>
-              <a:t>도구·참고  </a:t>
-            </a:r>
-            <a:r>
-              <a:rPr sz="1050" b="0">
+              <a:t>•  </a:t>
+            </a:r>
+            <a:r>
+              <a:rPr sz="1250" b="0" u="sng">
+                <a:solidFill>
+                  <a:srgbClr val="2F5BD8"/>
+                </a:solidFill>
+                <a:latin typeface="Pretendard"/>
+                <a:hlinkClick r:id="rId4"/>
+              </a:rPr>
+              <a:t>도구 3  포트폴리오 빌더</a:t>
+            </a:r>
+          </a:p>
+          <a:p>
+            <a:pPr algn="l">
+              <a:lnSpc>
+                <a:spcPct val="125000"/>
+              </a:lnSpc>
+            </a:pPr>
+            <a:r>
+              <a:rPr sz="1250" b="0">
                 <a:solidFill>
                   <a:srgbClr val="4A5070"/>
                 </a:solidFill>
                 <a:latin typeface="Pretendard"/>
               </a:rPr>
-              <a:t>[도구 1] 기업·경험 찾기 · [도구 2] AI 자기소개서 · [도구 3] 포트폴리오 빌더 | GitHub README · Hugging Face Model Cards · Amazon 면접 안내</a:t>
+              <a:t>•  </a:t>
+            </a:r>
+            <a:r>
+              <a:rPr sz="1250" b="0" u="sng">
+                <a:solidFill>
+                  <a:srgbClr val="2F5BD8"/>
+                </a:solidFill>
+                <a:latin typeface="Pretendard"/>
+                <a:hlinkClick r:id="rId5"/>
+              </a:rPr>
+              <a:t>GitHub README 가이드</a:t>
+            </a:r>
+          </a:p>
+          <a:p>
+            <a:pPr algn="l">
+              <a:lnSpc>
+                <a:spcPct val="125000"/>
+              </a:lnSpc>
+            </a:pPr>
+            <a:r>
+              <a:rPr sz="1250" b="0">
+                <a:solidFill>
+                  <a:srgbClr val="4A5070"/>
+                </a:solidFill>
+                <a:latin typeface="Pretendard"/>
+              </a:rPr>
+              <a:t>•  </a:t>
+            </a:r>
+            <a:r>
+              <a:rPr sz="1250" b="0" u="sng">
+                <a:solidFill>
+                  <a:srgbClr val="2F5BD8"/>
+                </a:solidFill>
+                <a:latin typeface="Pretendard"/>
+                <a:hlinkClick r:id="rId6"/>
+              </a:rPr>
+              <a:t>Hugging Face Model Cards</a:t>
+            </a:r>
+          </a:p>
+          <a:p>
+            <a:pPr algn="l">
+              <a:lnSpc>
+                <a:spcPct val="125000"/>
+              </a:lnSpc>
+            </a:pPr>
+            <a:r>
+              <a:rPr sz="1250" b="0">
+                <a:solidFill>
+                  <a:srgbClr val="4A5070"/>
+                </a:solidFill>
+                <a:latin typeface="Pretendard"/>
+              </a:rPr>
+              <a:t>•  </a:t>
+            </a:r>
+            <a:r>
+              <a:rPr sz="1250" b="0" u="sng">
+                <a:solidFill>
+                  <a:srgbClr val="2F5BD8"/>
+                </a:solidFill>
+                <a:latin typeface="Pretendard"/>
+                <a:hlinkClick r:id="rId7"/>
+              </a:rPr>
+              <a:t>Amazon 면접 준비 안내</a:t>
             </a:r>
           </a:p>
         </p:txBody>
@@ -5742,8 +5923,8 @@
         </p:nvSpPr>
         <p:spPr>
           <a:xfrm>
-            <a:off x="7747000" y="5346700"/>
-            <a:ext cx="3937000" cy="952500"/>
+            <a:off x="508000" y="6642100"/>
+            <a:ext cx="11176000" cy="152400"/>
           </a:xfrm>
           <a:prstGeom prst="rect">
             <a:avLst/>
@@ -5751,86 +5932,24 @@
           <a:noFill/>
         </p:spPr>
         <p:txBody>
-          <a:bodyPr wrap="square" lIns="25400" rIns="25400" tIns="12700" bIns="12700">
-            <a:spAutoFit/>
+          <a:bodyPr wrap="square" anchor="t" lIns="0" rIns="0" tIns="0" bIns="0">
+            <a:noAutofit/>
           </a:bodyPr>
           <a:lstStyle/>
           <a:p>
-            <a:r>
-              <a:rPr sz="1100" b="1">
-                <a:solidFill>
-                  <a:srgbClr val="10A37F"/>
-                </a:solidFill>
-                <a:latin typeface="Pretendard"/>
-              </a:rPr>
-              <a:t>관련 경험</a:t>
-            </a:r>
-          </a:p>
-          <a:p>
-            <a:r>
-              <a:rPr sz="1100" b="0">
-                <a:solidFill>
-                  <a:srgbClr val="4A5070"/>
-                </a:solidFill>
-                <a:latin typeface="Pretendard"/>
-              </a:rPr>
-              <a:t>오즈 AI헬스케어 이력서·포트폴리오 상담</a:t>
-            </a:r>
-          </a:p>
-          <a:p>
-            <a:r>
-              <a:rPr sz="1100" b="0">
-                <a:solidFill>
-                  <a:srgbClr val="4A5070"/>
-                </a:solidFill>
-                <a:latin typeface="Pretendard"/>
-              </a:rPr>
-              <a:t>엘리스 AI·SW 커리어 컨설팅</a:t>
-            </a:r>
-          </a:p>
-          <a:p>
-            <a:r>
-              <a:rPr sz="1100" b="0">
-                <a:solidFill>
-                  <a:srgbClr val="4A5070"/>
-                </a:solidFill>
-                <a:latin typeface="Pretendard"/>
-              </a:rPr>
-              <a:t>SSAFY 자기소개서·면접 지도</a:t>
-            </a:r>
-          </a:p>
-        </p:txBody>
-      </p:sp>
-      <p:sp>
-        <p:nvSpPr>
-          <p:cNvPr id="64" name="TextBox 63"/>
-          <p:cNvSpPr txBox="1"/>
-          <p:nvPr/>
-        </p:nvSpPr>
-        <p:spPr>
-          <a:xfrm>
-            <a:off x="381000" y="6629400"/>
-            <a:ext cx="11430000" cy="165100"/>
-          </a:xfrm>
-          <a:prstGeom prst="rect">
-            <a:avLst/>
-          </a:prstGeom>
-          <a:noFill/>
-        </p:spPr>
-        <p:txBody>
-          <a:bodyPr wrap="square" lIns="25400" rIns="25400" tIns="12700" bIns="12700">
-            <a:spAutoFit/>
-          </a:bodyPr>
-          <a:lstStyle/>
-          <a:p>
-            <a:r>
-              <a:rPr sz="900" b="0">
+            <a:pPr algn="l">
+              <a:lnSpc>
+                <a:spcPct val="115000"/>
+              </a:lnSpc>
+            </a:pPr>
+            <a:r>
+              <a:rPr sz="1000" b="0">
                 <a:solidFill>
                   <a:srgbClr val="8A90A8"/>
                 </a:solidFill>
                 <a:latin typeface="Pretendard"/>
               </a:rPr>
-              <a:t>각 회기 2시간 × 4모듈 = 8시간 · 휴게·점심 별도 · 산출물 범위는 수준별 조정</a:t>
+              <a:t>사전 준비: 노트북 · 채용공고 · 프로젝트 자료 · 이력서   |   휴게·점심 별도, 산출물 범위는 수준별 조정</a:t>
             </a:r>
           </a:p>
         </p:txBody>

</xml_diff>